<commit_message>
Corregir incoherencias de la Guía 1.5 y la presentación antes de la exposición
- Asignatura: "Portafolio de Título APT122 (Capstone)" en vez de "PTY4614"
- Se retira "20 créditos" (no verificable); la carga de 12-15 h/sem se atribuye al líder, no a cada integrante
- Plan de trabajo: fila "Segunda ronda del modelo" en S12, coherente con el Anexo A y la Gantt
- El frontend arranca en S4 (PR #14): Gantt continua S4-S13, plan "semanas 4 a 7", nota de la lámina 7
- Índice de la Guía actualizado; 17 páginas sin huecos

Co-Authored-By: Claude Fable 5.1 <noreply@anthropic.com>
Claude-Session: https://claude.ai/code/session_01Rvh88dkfXqgVzQiFw1YokL
</commit_message>
<xml_diff>
--- a/Fase 1/Evidencias Grupales/Presentación Proyecto.pptx
+++ b/Fase 1/Evidencias Grupales/Presentación Proyecto.pptx
@@ -1322,7 +1322,7 @@
           <a:lstStyle/>
           <a:p>
             <a:r>
-              <a:t>2:00 · Liân. Leer el cronograma por hitos, no por filas: H1 hoy; H2 en la S9 el recorrido completo funciona; H3 evaluación de avance en S10; H4 entrega v1.0.0 en S15; H5 defensa en S18. Señalar que el frontend corre en paralelo desde la S6 gracias al contrato congelado, y que el etiquetado (S5-S8) es la tarea que hacen los tres.</a:t>
+              <a:t>2:00 · Liân. Leer el cronograma por hitos, no por filas: H1 hoy; H2 en la S9 el recorrido completo funciona; H3 evaluación de avance en S10; H4 entrega v1.0.0 en S15; H5 defensa en S18. Señalar que el frontend corre en paralelo desde la S4 gracias al contrato congelado, y que el etiquetado (S5-S8) es la tarea que hacen los tres.</a:t>
             </a:r>
           </a:p>
         </p:txBody>
@@ -11955,7 +11955,7 @@
                 </a:solidFill>
                 <a:latin typeface="Calibri"/>
               </a:rPr>
-              <a:t>Capstone (PTY4614)  ·  Ingeniería en Informática  ·  Duoc UC  ·  septiembre de 2026</a:t>
+              <a:t>Portafolio de Título APT122 (Capstone)  ·  Ingeniería en Informática  ·  Duoc UC  ·  septiembre de 2026</a:t>
             </a:r>
           </a:p>
         </p:txBody>
@@ -19227,7 +19227,7 @@
                   </a:txBody>
                   <a:tcPr marL="27432" marR="27432" marT="9144" marB="9144" anchor="ctr">
                     <a:solidFill>
-                      <a:srgbClr val="FFFFFF"/>
+                      <a:srgbClr val="8C8C8C"/>
                     </a:solidFill>
                   </a:tcPr>
                 </a:tc>

</xml_diff>

<commit_message>
Completar datos de sede, docente y apellido de Lian en la Guía 1.5 y la presentación
- Sede: Padre Alonso Ovalle · Docente: Felix Eduardo Cifuentes Cid
- Lian Grandón en antecedentes, intereses, conclusiones, plan, bibliografía y láminas 1 y 2
- Los RUT siguen como marcador [[RUT]]: no entran al repositorio
- Quedan los marcadores de los párrafos que Miguel y Lian deben escribir con sus palabras
- Índice actualizado; 17 páginas

Co-Authored-By: Claude Fable 5.1 <noreply@anthropic.com>
Claude-Session: https://claude.ai/code/session_01Rvh88dkfXqgVzQiFw1YokL
</commit_message>
<xml_diff>
--- a/Fase 1/Evidencias Grupales/Presentación Proyecto.pptx
+++ b/Fase 1/Evidencias Grupales/Presentación Proyecto.pptx
@@ -740,7 +740,7 @@
           <a:lstStyle/>
           <a:p>
             <a:r>
-              <a:t>0:30 · Edgar. Saludo a la comisión (gerencia de proyecto). Una frase: 'Guardián EPP convierte el video que la obra ya graba en eventos de incumplimiento de EPP con alerta, evidencia y analítica'. Reparto sugerido para que la participación sea equitativa (IE 13): Edgar láminas 1, 3 y 8 · Miguel láminas 4 y 5 · Liân láminas 6 y 7. Lámina 2: cada uno se presenta a sí mismo. Total 15 minutos.</a:t>
+              <a:t>0:30 · Edgar. Saludo a la comisión (gerencia de proyecto). Una frase: 'Guardián EPP convierte el video que la obra ya graba en eventos de incumplimiento de EPP con alerta, evidencia y analítica'. Reparto sugerido para que la participación sea equitativa (IE 13): Edgar láminas 1, 3 y 8 · Miguel láminas 4 y 5 · Lian láminas 6 y 7. Lámina 2: cada uno se presenta a sí mismo. Total 15 minutos.</a:t>
             </a:r>
           </a:p>
         </p:txBody>
@@ -837,7 +837,7 @@
           <a:lstStyle/>
           <a:p>
             <a:r>
-              <a:t>0:30 · Cada integrante dice su nombre, su rol y en una frase de qué responde. Edgar: visión, backend, datos e infraestructura. Miguel: bandeja, visor y reglas. Liân: analítica, reportes y administración. Roles cruzados: el etiquetado lo hacen los tres.</a:t>
+              <a:t>0:30 · Cada integrante dice su nombre, su rol y en una frase de qué responde. Edgar: visión, backend, datos e infraestructura. Miguel: bandeja, visor y reglas. Lian: analítica, reportes y administración. Roles cruzados: el etiquetado lo hacen los tres.</a:t>
             </a:r>
           </a:p>
         </p:txBody>
@@ -1225,7 +1225,7 @@
           <a:lstStyle/>
           <a:p>
             <a:r>
-              <a:t>2:30 · Liân. Contar el principio (integrar en S9) y luego pasar por las seis prácticas en una frase cada una. Ejemplo concreto del paralelismo: el diseño de la interfaz ya está aprobado y el contrato congelado, por eso el frontend empieza esta semana. Ejemplo de verificación: medimos los píxeles del casco y descubrimos que en un mismo encuadre hay zonas evaluables y zonas que no.</a:t>
+              <a:t>2:30 · Lian. Contar el principio (integrar en S9) y luego pasar por las seis prácticas en una frase cada una. Ejemplo concreto del paralelismo: el diseño de la interfaz ya está aprobado y el contrato congelado, por eso el frontend empieza esta semana. Ejemplo de verificación: medimos los píxeles del casco y descubrimos que en un mismo encuadre hay zonas evaluables y zonas que no.</a:t>
             </a:r>
           </a:p>
         </p:txBody>
@@ -1322,7 +1322,7 @@
           <a:lstStyle/>
           <a:p>
             <a:r>
-              <a:t>2:00 · Liân. Leer el cronograma por hitos, no por filas: H1 hoy; H2 en la S9 el recorrido completo funciona; H3 evaluación de avance en S10; H4 entrega v1.0.0 en S15; H5 defensa en S18. Señalar que el frontend corre en paralelo desde la S4 gracias al contrato congelado, y que el etiquetado (S5-S8) es la tarea que hacen los tres.</a:t>
+              <a:t>2:00 · Lian. Leer el cronograma por hitos, no por filas: H1 hoy; H2 en la S9 el recorrido completo funciona; H3 evaluación de avance en S10; H4 entrega v1.0.0 en S15; H5 defensa en S18. Señalar que el frontend corre en paralelo desde la S4 gracias al contrato congelado, y que el etiquetado (S5-S8) es la tarea que hacen los tres.</a:t>
             </a:r>
           </a:p>
         </p:txBody>
@@ -11936,7 +11936,7 @@
                 </a:solidFill>
                 <a:latin typeface="Calibri"/>
               </a:rPr>
-              <a:t>Edgar Tolentino  ·  Miguel Ortega  ·  Liân</a:t>
+              <a:t>Edgar Tolentino  ·  Miguel Ortega  ·  Lian Grandón</a:t>
             </a:r>
           </a:p>
           <a:p>
@@ -12651,7 +12651,7 @@
                   <a:cs typeface="Calibri"/>
                   <a:sym typeface="Calibri"/>
                 </a:rPr>
-                <a:t>Liân</a:t>
+                <a:t>Lian Grandón</a:t>
               </a:r>
               <a:endParaRPr sz="2600" b="0" i="0" u="none" strike="noStrike" cap="none">
                 <a:solidFill>

</xml_diff>

<commit_message>
docs: lámina 8 en lenguaje llano y con el flujo de izquierda a derecha
Edgar la va a explicar al docente y a los alumnos: salen RTSP, MediaMTX,
capture_ts, "inferir" y los nombres de módulo como etiqueta principal.
Cada tecnología queda con una frase sin jerga, las cuatro etapas van en
columnas con flechas y la franja "cómo se construye" pasa abajo. Las
notas del expositor traen las respuestas a las preguntas probables: por
qué no YOLO, qué es Redis, qué es ONNX, qué es RTSP.

Co-Authored-By: Claude Fable 5.1 <noreply@anthropic.com>
Claude-Session: https://claude.ai/code/session_01Rvh88dkfXqgVzQiFw1YokL
</commit_message>
<xml_diff>
--- a/Fase 1/Evidencias Grupales/Presentación Proyecto.pptx
+++ b/Fase 1/Evidencias Grupales/Presentación Proyecto.pptx
@@ -1419,7 +1419,7 @@
           <a:lstStyle/>
           <a:p>
             <a:r>
-              <a:t>3:00 · Edgar. Cuatro filas de arriba abajo y, en cada caja, la tecnología y una frase de lo que hace. (1) Entrada: el trabajador toma los .mp4 que la obra ya graba; OpenCV los muestrea a 5 cuadros por segundo y aplica las máscaras de privacidad; el reloj nace en la captura. (2) Visión: RF-DETR detecta persona, casco y chaleco, Apache-2.0, por eso no YOLO; ByteTrack sigue con identificadores efímeros; el modelo exportado a ONNX corre en CPU en cualquier portátil. (3) Decisión y datos: gepp-core convierte trayectorias en hallazgos con umbrales en segundos; PostgreSQL guarda detecciones crudas y reglas versionadas, y por eso se puede recalcular sin GPU; Redis desacopla. (4) Servicios e interfaz: FastAPI cumple el contrato congelado y no importa la visión; React construye bandeja, visor, reglas y tablero contra Prism hasta la S9; el canal de alerta cierra el ciclo con acuse y seis avisos por turno como máximo. La columna derecha es cómo se trabaja: uv, pruebas y tipado, CI que rechaza licencias AGPL, Docker Compose, Prism y CVAT. Cerrar con la línea de abajo: la Etapa 1 decide, la Etapa 2 describe; el evento, no el cuadro, es la unidad.</a:t>
+              <a:t>3:00 · Edgar. Leer el flujo de izquierda a derecha, una columna por vez. (1) Entra el video: la obra deja sus grabaciones en una carpeta y el sistema las toma solo; OpenCV lee el video, se queda con 5 cuadros por segundo, tapa las zonas que no se deben analizar y difumina rostros antes de guardar; cada cuadro queda fechado con la hora real de la grabación. (2) Se detecta y se sigue: RF-DETR es el modelo que marca personas, cascos y chalecos, entrenado con nuestras imágenes; es de licencia libre y por eso no usamos YOLO, cuya licencia AGPL alcanza a los modelos entrenados y obligaría a liberar todo el sistema. ByteTrack sigue a cada persona de un cuadro al siguiente con un número temporal: nunca sabemos quién es. ONNX Runtime hace que el modelo, entrenado una vez con GPU, corra en cualquier computador. (3) Se decide y se guarda: el motor de reglas, código propio, convierte recorridos en hallazgos según las reglas de la obra, medidas en segundos; PostgreSQL guarda todo, incluidas las detecciones cuadro a cuadro, y por eso se puede cambiar una regla y recalcular sin reprocesar video; Redis es la fila de espera de los videos. (4) Se usa: FastAPI entrega los datos a la web bajo un contrato acordado antes de programar; React es la web que construyen Miguel y Lian; la alerta llega por Telegram o correo con acuse de recibo y un máximo de seis avisos por turno. Abajo, cómo se construye. Cerrar con la línea final: el detector y las reglas deciden, la descripción con IA solo describe, y la unidad es el evento. Si preguntan por las cámaras en vivo: RTSP es el protocolo de las cámaras IP; la versión 2 se conecta a cámaras en vez de leer archivos y se prueba desde la semana 6 simulando una cámara con un video grabado (MediaMTX).</a:t>
             </a:r>
           </a:p>
         </p:txBody>
@@ -22384,7 +22384,7 @@
                 <a:cs typeface="Calibri"/>
                 <a:sym typeface="Calibri"/>
               </a:rPr>
-              <a:t>Del video que la obra ya graba al hallazgo con evidencia. Cada pieza: la tecnología y lo que hace.</a:t>
+              <a:t>Cómo viaja el video hasta convertirse en un hallazgo con evidencia. En cada caja: una tecnología y lo que hace.</a:t>
             </a:r>
             <a:endParaRPr/>
           </a:p>
@@ -22424,8 +22424,8 @@
         </p:nvSpPr>
         <p:spPr>
           <a:xfrm>
-            <a:off x="365760" y="2395728"/>
-            <a:ext cx="1554480" cy="841248"/>
+            <a:off x="365760" y="2331720"/>
+            <a:ext cx="2624328" cy="512064"/>
           </a:xfrm>
           <a:prstGeom prst="roundRect">
             <a:avLst>
@@ -22469,13 +22469,13 @@
               </a:spcAft>
             </a:pPr>
             <a:r>
-              <a:rPr sz="1100" b="1" i="0">
+              <a:rPr sz="1200" b="1" i="0">
                 <a:solidFill>
                   <a:srgbClr val="FFFFFF"/>
                 </a:solidFill>
                 <a:latin typeface="Calibri"/>
               </a:rPr>
-              <a:t>1 · ENTRADA</a:t>
+              <a:t>1 · ENTRA EL VIDEO</a:t>
             </a:r>
           </a:p>
           <a:p>
@@ -22488,13 +22488,13 @@
               </a:spcAft>
             </a:pPr>
             <a:r>
-              <a:rPr sz="950" b="0" i="0">
+              <a:rPr sz="900" b="0" i="0">
                 <a:solidFill>
                   <a:srgbClr val="FFFFFF"/>
                 </a:solidFill>
                 <a:latin typeface="Calibri"/>
               </a:rPr>
-              <a:t>gepp-worker</a:t>
+              <a:t>código propio: gepp-worker</a:t>
             </a:r>
           </a:p>
         </p:txBody>
@@ -22507,8 +22507,8 @@
         </p:nvSpPr>
         <p:spPr>
           <a:xfrm>
-            <a:off x="2057400" y="2395728"/>
-            <a:ext cx="3831336" cy="841248"/>
+            <a:off x="365760" y="2916936"/>
+            <a:ext cx="2624328" cy="1339595"/>
           </a:xfrm>
           <a:prstGeom prst="roundRect">
             <a:avLst>
@@ -22552,13 +22552,13 @@
               </a:spcAft>
             </a:pPr>
             <a:r>
-              <a:rPr sz="1200" b="1" i="0">
+              <a:rPr sz="1150" b="1" i="0">
                 <a:solidFill>
                   <a:srgbClr val="1F3864"/>
                 </a:solidFill>
                 <a:latin typeface="Calibri"/>
               </a:rPr>
-              <a:t>Carpeta vigilada (v1) · RTSP (v2)</a:t>
+              <a:t>Carpeta vigilada</a:t>
             </a:r>
           </a:p>
           <a:p>
@@ -22571,13 +22571,13 @@
               </a:spcAft>
             </a:pPr>
             <a:r>
-              <a:rPr sz="1000" b="0" i="0">
+              <a:rPr sz="950" b="0" i="0">
                 <a:solidFill>
                   <a:srgbClr val="1C1C1C"/>
                 </a:solidFill>
                 <a:latin typeface="Calibri"/>
               </a:rPr>
-              <a:t>Toma los .mp4 que la obra ya graba; en v2, cámaras RTSP (MediaMTX las simula desde la S6). El reloj nace en la captura: capture_ts.</a:t>
+              <a:t>La obra deja sus grabaciones en una carpeta y el sistema las toma solo. Cada cuadro queda fechado con la hora real en que se grabó. Más adelante: cámaras en vivo, con el mismo diseño.</a:t>
             </a:r>
           </a:p>
         </p:txBody>
@@ -22590,8 +22590,8 @@
         </p:nvSpPr>
         <p:spPr>
           <a:xfrm>
-            <a:off x="5998464" y="2395728"/>
-            <a:ext cx="3831336" cy="841248"/>
+            <a:off x="365760" y="4329683"/>
+            <a:ext cx="2624328" cy="1339595"/>
           </a:xfrm>
           <a:prstGeom prst="roundRect">
             <a:avLst>
@@ -22635,13 +22635,13 @@
               </a:spcAft>
             </a:pPr>
             <a:r>
-              <a:rPr sz="1200" b="1" i="0">
+              <a:rPr sz="1150" b="1" i="0">
                 <a:solidFill>
                   <a:srgbClr val="1F3864"/>
                 </a:solidFill>
                 <a:latin typeface="Calibri"/>
               </a:rPr>
-              <a:t>OpenCV + FFmpeg</a:t>
+              <a:t>OpenCV</a:t>
             </a:r>
           </a:p>
           <a:p>
@@ -22654,13 +22654,13 @@
               </a:spcAft>
             </a:pPr>
             <a:r>
-              <a:rPr sz="1000" b="0" i="0">
+              <a:rPr sz="950" b="0" i="0">
                 <a:solidFill>
                   <a:srgbClr val="1C1C1C"/>
                 </a:solidFill>
                 <a:latin typeface="Calibri"/>
               </a:rPr>
-              <a:t>Decodifica el video, lo muestrea a 5 fps y aplica las máscaras de privacidad antes de inferir. Difumina los rostros de la evidencia.</a:t>
+              <a:t>Abre el video y se queda con 5 cuadros por segundo. Tapa las zonas que no se deben analizar y difumina los rostros antes de guardar cualquier imagen.</a:t>
             </a:r>
           </a:p>
         </p:txBody>
@@ -22673,8 +22673,8 @@
         </p:nvSpPr>
         <p:spPr>
           <a:xfrm>
-            <a:off x="365760" y="3383280"/>
-            <a:ext cx="1554480" cy="841248"/>
+            <a:off x="3300984" y="2331720"/>
+            <a:ext cx="2624328" cy="512064"/>
           </a:xfrm>
           <a:prstGeom prst="roundRect">
             <a:avLst>
@@ -22718,13 +22718,13 @@
               </a:spcAft>
             </a:pPr>
             <a:r>
-              <a:rPr sz="1100" b="1" i="0">
+              <a:rPr sz="1200" b="1" i="0">
                 <a:solidFill>
                   <a:srgbClr val="FFFFFF"/>
                 </a:solidFill>
                 <a:latin typeface="Calibri"/>
               </a:rPr>
-              <a:t>2 · VISIÓN</a:t>
+              <a:t>2 · SE DETECTA Y SE SIGUE</a:t>
             </a:r>
           </a:p>
           <a:p>
@@ -22737,53 +22737,61 @@
               </a:spcAft>
             </a:pPr>
             <a:r>
-              <a:rPr sz="950" b="0" i="0">
+              <a:rPr sz="900" b="0" i="0">
                 <a:solidFill>
                   <a:srgbClr val="FFFFFF"/>
                 </a:solidFill>
                 <a:latin typeface="Calibri"/>
               </a:rPr>
-              <a:t>gepp-vision</a:t>
+              <a:t>código propio: gepp-vision</a:t>
             </a:r>
           </a:p>
         </p:txBody>
       </p:sp>
-      <p:cxnSp>
-        <p:nvCxnSpPr>
-          <p:cNvPr id="162" name="Connector 161"/>
-          <p:cNvCxnSpPr/>
+      <p:sp>
+        <p:nvSpPr>
+          <p:cNvPr id="162" name="Right Arrow 161"/>
+          <p:cNvSpPr/>
           <p:nvPr/>
-        </p:nvCxnSpPr>
+        </p:nvSpPr>
         <p:spPr>
           <a:xfrm>
-            <a:off x="1143000" y="3236976"/>
-            <a:ext cx="0" cy="146304"/>
+            <a:off x="3017520" y="2432304"/>
+            <a:ext cx="256032" cy="310896"/>
           </a:xfrm>
-          <a:prstGeom prst="line">
+          <a:prstGeom prst="rightArrow">
             <a:avLst/>
           </a:prstGeom>
-          <a:ln w="19050">
-            <a:solidFill>
-              <a:srgbClr val="1F3864"/>
-            </a:solidFill>
-            <a:tailEnd type="triangle" w="med" len="med"/>
+          <a:solidFill>
+            <a:srgbClr val="1F3864"/>
+          </a:solidFill>
+          <a:ln>
+            <a:noFill/>
           </a:ln>
+          <a:effectLst/>
         </p:spPr>
         <p:style>
-          <a:lnRef idx="2">
+          <a:lnRef idx="1">
             <a:schemeClr val="accent1"/>
           </a:lnRef>
-          <a:fillRef idx="0">
+          <a:fillRef idx="3">
             <a:schemeClr val="accent1"/>
           </a:fillRef>
-          <a:effectRef idx="1">
+          <a:effectRef idx="2">
             <a:schemeClr val="accent1"/>
           </a:effectRef>
           <a:fontRef idx="minor">
-            <a:schemeClr val="tx1"/>
+            <a:schemeClr val="lt1"/>
           </a:fontRef>
         </p:style>
-      </p:cxnSp>
+        <p:txBody>
+          <a:bodyPr rtlCol="0" anchor="ctr"/>
+          <a:lstStyle/>
+          <a:p>
+            <a:pPr algn="ctr"/>
+          </a:p>
+        </p:txBody>
+      </p:sp>
       <p:sp>
         <p:nvSpPr>
           <p:cNvPr id="163" name="Rounded Rectangle 162"/>
@@ -22792,8 +22800,8 @@
         </p:nvSpPr>
         <p:spPr>
           <a:xfrm>
-            <a:off x="2057400" y="3383280"/>
-            <a:ext cx="2517648" cy="841248"/>
+            <a:off x="3300984" y="2916936"/>
+            <a:ext cx="2624328" cy="868679"/>
           </a:xfrm>
           <a:prstGeom prst="roundRect">
             <a:avLst>
@@ -22837,13 +22845,13 @@
               </a:spcAft>
             </a:pPr>
             <a:r>
-              <a:rPr sz="1200" b="1" i="0">
+              <a:rPr sz="1150" b="1" i="0">
                 <a:solidFill>
                   <a:srgbClr val="1F3864"/>
                 </a:solidFill>
                 <a:latin typeface="Calibri"/>
               </a:rPr>
-              <a:t>RF-DETR (Apache-2.0)</a:t>
+              <a:t>RF-DETR · el detector</a:t>
             </a:r>
           </a:p>
           <a:p>
@@ -22856,13 +22864,13 @@
               </a:spcAft>
             </a:pPr>
             <a:r>
-              <a:rPr sz="1000" b="0" i="0">
+              <a:rPr sz="950" b="0" i="0">
                 <a:solidFill>
                   <a:srgbClr val="1C1C1C"/>
                 </a:solidFill>
                 <a:latin typeface="Calibri"/>
               </a:rPr>
-              <a:t>Detector: encuentra personas, cascos y chalecos en cada cuadro. Se afina con imágenes propias.</a:t>
+              <a:t>Marca en cada cuadro dónde hay personas, cascos y chalecos. Se entrena con nuestras imágenes. Licencia libre, por eso no YOLO.</a:t>
             </a:r>
           </a:p>
         </p:txBody>
@@ -22875,8 +22883,8 @@
         </p:nvSpPr>
         <p:spPr>
           <a:xfrm>
-            <a:off x="4684776" y="3383280"/>
-            <a:ext cx="2517648" cy="841248"/>
+            <a:off x="3300984" y="3858768"/>
+            <a:ext cx="2624328" cy="868679"/>
           </a:xfrm>
           <a:prstGeom prst="roundRect">
             <a:avLst>
@@ -22920,13 +22928,13 @@
               </a:spcAft>
             </a:pPr>
             <a:r>
-              <a:rPr sz="1200" b="1" i="0">
+              <a:rPr sz="1150" b="1" i="0">
                 <a:solidFill>
                   <a:srgbClr val="1F3864"/>
                 </a:solidFill>
                 <a:latin typeface="Calibri"/>
               </a:rPr>
-              <a:t>ByteTrack (roboflow/trackers)</a:t>
+              <a:t>ByteTrack · el seguidor</a:t>
             </a:r>
           </a:p>
           <a:p>
@@ -22939,13 +22947,13 @@
               </a:spcAft>
             </a:pPr>
             <a:r>
-              <a:rPr sz="1000" b="0" i="0">
+              <a:rPr sz="950" b="0" i="0">
                 <a:solidFill>
                   <a:srgbClr val="1C1C1C"/>
                 </a:solidFill>
                 <a:latin typeface="Calibri"/>
               </a:rPr>
-              <a:t>Seguidor: une detecciones en trayectorias con track_id efímero, sin reidentificar personas.</a:t>
+              <a:t>Sigue a cada persona de un cuadro al siguiente y arma su recorrido. Le da un número temporal, nunca una identidad.</a:t>
             </a:r>
           </a:p>
         </p:txBody>
@@ -22958,8 +22966,8 @@
         </p:nvSpPr>
         <p:spPr>
           <a:xfrm>
-            <a:off x="7312152" y="3383280"/>
-            <a:ext cx="2517648" cy="841248"/>
+            <a:off x="3300984" y="4800600"/>
+            <a:ext cx="2624328" cy="868679"/>
           </a:xfrm>
           <a:prstGeom prst="roundRect">
             <a:avLst>
@@ -23003,13 +23011,13 @@
               </a:spcAft>
             </a:pPr>
             <a:r>
-              <a:rPr sz="1200" b="1" i="0">
+              <a:rPr sz="1150" b="1" i="0">
                 <a:solidFill>
                   <a:srgbClr val="1F3864"/>
                 </a:solidFill>
                 <a:latin typeface="Calibri"/>
               </a:rPr>
-              <a:t>PyTorch → ONNX Runtime</a:t>
+              <a:t>ONNX Runtime · la ejecución</a:t>
             </a:r>
           </a:p>
           <a:p>
@@ -23022,13 +23030,13 @@
               </a:spcAft>
             </a:pPr>
             <a:r>
-              <a:rPr sz="1000" b="0" i="0">
+              <a:rPr sz="950" b="0" i="0">
                 <a:solidFill>
                   <a:srgbClr val="1C1C1C"/>
                 </a:solidFill>
                 <a:latin typeface="Calibri"/>
               </a:rPr>
-              <a:t>Entrena en GPU (nube con datos públicos, local con los propios) y ejecuta en CPU en cualquier portátil.</a:t>
+              <a:t>El modelo se entrena una vez con tarjeta gráfica (GPU) y después corre en cualquier computador normal, sin GPU.</a:t>
             </a:r>
           </a:p>
         </p:txBody>
@@ -23041,8 +23049,8 @@
         </p:nvSpPr>
         <p:spPr>
           <a:xfrm>
-            <a:off x="365760" y="4370832"/>
-            <a:ext cx="1554480" cy="841248"/>
+            <a:off x="6236208" y="2331720"/>
+            <a:ext cx="2624328" cy="512064"/>
           </a:xfrm>
           <a:prstGeom prst="roundRect">
             <a:avLst>
@@ -23086,13 +23094,13 @@
               </a:spcAft>
             </a:pPr>
             <a:r>
-              <a:rPr sz="1100" b="1" i="0">
+              <a:rPr sz="1200" b="1" i="0">
                 <a:solidFill>
                   <a:srgbClr val="FFFFFF"/>
                 </a:solidFill>
                 <a:latin typeface="Calibri"/>
               </a:rPr>
-              <a:t>3 · DECISIÓN Y DATOS</a:t>
+              <a:t>3 · SE DECIDE Y SE GUARDA</a:t>
             </a:r>
           </a:p>
           <a:p>
@@ -23105,53 +23113,61 @@
               </a:spcAft>
             </a:pPr>
             <a:r>
-              <a:rPr sz="950" b="0" i="0">
+              <a:rPr sz="900" b="0" i="0">
                 <a:solidFill>
                   <a:srgbClr val="FFFFFF"/>
                 </a:solidFill>
                 <a:latin typeface="Calibri"/>
               </a:rPr>
-              <a:t>gepp-core · PostgreSQL</a:t>
+              <a:t>código propio: gepp-core</a:t>
             </a:r>
           </a:p>
         </p:txBody>
       </p:sp>
-      <p:cxnSp>
-        <p:nvCxnSpPr>
-          <p:cNvPr id="167" name="Connector 166"/>
-          <p:cNvCxnSpPr/>
+      <p:sp>
+        <p:nvSpPr>
+          <p:cNvPr id="167" name="Right Arrow 166"/>
+          <p:cNvSpPr/>
           <p:nvPr/>
-        </p:nvCxnSpPr>
+        </p:nvSpPr>
         <p:spPr>
           <a:xfrm>
-            <a:off x="1143000" y="4224528"/>
-            <a:ext cx="0" cy="146304"/>
+            <a:off x="5952744" y="2432304"/>
+            <a:ext cx="256032" cy="310896"/>
           </a:xfrm>
-          <a:prstGeom prst="line">
+          <a:prstGeom prst="rightArrow">
             <a:avLst/>
           </a:prstGeom>
-          <a:ln w="19050">
-            <a:solidFill>
-              <a:srgbClr val="1F3864"/>
-            </a:solidFill>
-            <a:tailEnd type="triangle" w="med" len="med"/>
+          <a:solidFill>
+            <a:srgbClr val="1F3864"/>
+          </a:solidFill>
+          <a:ln>
+            <a:noFill/>
           </a:ln>
+          <a:effectLst/>
         </p:spPr>
         <p:style>
-          <a:lnRef idx="2">
+          <a:lnRef idx="1">
             <a:schemeClr val="accent1"/>
           </a:lnRef>
-          <a:fillRef idx="0">
+          <a:fillRef idx="3">
             <a:schemeClr val="accent1"/>
           </a:fillRef>
-          <a:effectRef idx="1">
+          <a:effectRef idx="2">
             <a:schemeClr val="accent1"/>
           </a:effectRef>
           <a:fontRef idx="minor">
-            <a:schemeClr val="tx1"/>
+            <a:schemeClr val="lt1"/>
           </a:fontRef>
         </p:style>
-      </p:cxnSp>
+        <p:txBody>
+          <a:bodyPr rtlCol="0" anchor="ctr"/>
+          <a:lstStyle/>
+          <a:p>
+            <a:pPr algn="ctr"/>
+          </a:p>
+        </p:txBody>
+      </p:sp>
       <p:sp>
         <p:nvSpPr>
           <p:cNvPr id="168" name="Rounded Rectangle 167"/>
@@ -23160,8 +23176,8 @@
         </p:nvSpPr>
         <p:spPr>
           <a:xfrm>
-            <a:off x="2057400" y="4370832"/>
-            <a:ext cx="2517648" cy="841248"/>
+            <a:off x="6236208" y="2916936"/>
+            <a:ext cx="2624328" cy="868679"/>
           </a:xfrm>
           <a:prstGeom prst="roundRect">
             <a:avLst>
@@ -23205,13 +23221,13 @@
               </a:spcAft>
             </a:pPr>
             <a:r>
-              <a:rPr sz="1200" b="1" i="0">
+              <a:rPr sz="1150" b="1" i="0">
                 <a:solidFill>
                   <a:srgbClr val="1F3864"/>
                 </a:solidFill>
                 <a:latin typeface="Calibri"/>
               </a:rPr>
-              <a:t>gepp-core (Python puro)</a:t>
+              <a:t>Motor de reglas</a:t>
             </a:r>
           </a:p>
           <a:p>
@@ -23224,13 +23240,13 @@
               </a:spcAft>
             </a:pPr>
             <a:r>
-              <a:rPr sz="1000" b="0" i="0">
+              <a:rPr sz="950" b="0" i="0">
                 <a:solidFill>
                   <a:srgbClr val="1C1C1C"/>
                 </a:solidFill>
                 <a:latin typeface="Calibri"/>
               </a:rPr>
-              <a:t>Motor de reglas y agregador: de trayectorias a hallazgos con inicio, término, zona y severidad, en segundos.</a:t>
+              <a:t>Aplica las reglas de la obra: X segundos sin casco donde se exige crean un hallazgo con inicio, término, zona y severidad.</a:t>
             </a:r>
           </a:p>
         </p:txBody>
@@ -23243,8 +23259,8 @@
         </p:nvSpPr>
         <p:spPr>
           <a:xfrm>
-            <a:off x="4684776" y="4370832"/>
-            <a:ext cx="2517648" cy="841248"/>
+            <a:off x="6236208" y="3858768"/>
+            <a:ext cx="2624328" cy="868679"/>
           </a:xfrm>
           <a:prstGeom prst="roundRect">
             <a:avLst>
@@ -23288,13 +23304,13 @@
               </a:spcAft>
             </a:pPr>
             <a:r>
-              <a:rPr sz="1200" b="1" i="0">
+              <a:rPr sz="1150" b="1" i="0">
                 <a:solidFill>
                   <a:srgbClr val="1F3864"/>
                 </a:solidFill>
                 <a:latin typeface="Calibri"/>
               </a:rPr>
-              <a:t>PostgreSQL 17 + Alembic</a:t>
+              <a:t>PostgreSQL · la base de datos</a:t>
             </a:r>
           </a:p>
           <a:p>
@@ -23307,13 +23323,13 @@
               </a:spcAft>
             </a:pPr>
             <a:r>
-              <a:rPr sz="1000" b="0" i="0">
+              <a:rPr sz="950" b="0" i="0">
                 <a:solidFill>
                   <a:srgbClr val="1C1C1C"/>
                 </a:solidFill>
                 <a:latin typeface="Calibri"/>
               </a:rPr>
-              <a:t>Guarda detecciones crudas, hallazgos, reglas versionadas y acuses. Permite recalcular reglas sin GPU.</a:t>
+              <a:t>Guarda hallazgos, detecciones cuadro a cuadro, reglas con historial y acuses. Así se recalculan reglas sin reprocesar video.</a:t>
             </a:r>
           </a:p>
         </p:txBody>
@@ -23326,8 +23342,8 @@
         </p:nvSpPr>
         <p:spPr>
           <a:xfrm>
-            <a:off x="7312152" y="4370832"/>
-            <a:ext cx="2517648" cy="841248"/>
+            <a:off x="6236208" y="4800600"/>
+            <a:ext cx="2624328" cy="868679"/>
           </a:xfrm>
           <a:prstGeom prst="roundRect">
             <a:avLst>
@@ -23371,13 +23387,13 @@
               </a:spcAft>
             </a:pPr>
             <a:r>
-              <a:rPr sz="1200" b="1" i="0">
+              <a:rPr sz="1150" b="1" i="0">
                 <a:solidFill>
                   <a:srgbClr val="1F3864"/>
                 </a:solidFill>
                 <a:latin typeface="Calibri"/>
               </a:rPr>
-              <a:t>Redis 7</a:t>
+              <a:t>Redis · la fila de espera</a:t>
             </a:r>
           </a:p>
           <a:p>
@@ -23390,13 +23406,13 @@
               </a:spcAft>
             </a:pPr>
             <a:r>
-              <a:rPr sz="1000" b="0" i="0">
+              <a:rPr sz="950" b="0" i="0">
                 <a:solidFill>
                   <a:srgbClr val="1C1C1C"/>
                 </a:solidFill>
                 <a:latin typeface="Calibri"/>
               </a:rPr>
-              <a:t>Cola de trabajos: desacopla la ingesta del procesamiento y del envío de avisos.</a:t>
+              <a:t>Fila de espera en memoria: los videos que llegan esperan su turno y se procesan uno a uno, sin bloquear ni perder nada.</a:t>
             </a:r>
           </a:p>
         </p:txBody>
@@ -23409,8 +23425,8 @@
         </p:nvSpPr>
         <p:spPr>
           <a:xfrm>
-            <a:off x="365760" y="5358384"/>
-            <a:ext cx="1554480" cy="841248"/>
+            <a:off x="9171432" y="2331720"/>
+            <a:ext cx="2624328" cy="512064"/>
           </a:xfrm>
           <a:prstGeom prst="roundRect">
             <a:avLst>
@@ -23454,13 +23470,13 @@
               </a:spcAft>
             </a:pPr>
             <a:r>
-              <a:rPr sz="1100" b="1" i="0">
+              <a:rPr sz="1200" b="1" i="0">
                 <a:solidFill>
                   <a:srgbClr val="FFFFFF"/>
                 </a:solidFill>
                 <a:latin typeface="Calibri"/>
               </a:rPr>
-              <a:t>4 · SERVICIOS E INTERFAZ</a:t>
+              <a:t>4 · SE USA</a:t>
             </a:r>
           </a:p>
           <a:p>
@@ -23473,53 +23489,61 @@
               </a:spcAft>
             </a:pPr>
             <a:r>
-              <a:rPr sz="950" b="0" i="0">
+              <a:rPr sz="900" b="0" i="0">
                 <a:solidFill>
                   <a:srgbClr val="FFFFFF"/>
                 </a:solidFill>
                 <a:latin typeface="Calibri"/>
               </a:rPr>
-              <a:t>gepp-api · apps/web</a:t>
+              <a:t>código propio: gepp-api · web</a:t>
             </a:r>
           </a:p>
         </p:txBody>
       </p:sp>
-      <p:cxnSp>
-        <p:nvCxnSpPr>
-          <p:cNvPr id="172" name="Connector 171"/>
-          <p:cNvCxnSpPr/>
+      <p:sp>
+        <p:nvSpPr>
+          <p:cNvPr id="172" name="Right Arrow 171"/>
+          <p:cNvSpPr/>
           <p:nvPr/>
-        </p:nvCxnSpPr>
+        </p:nvSpPr>
         <p:spPr>
           <a:xfrm>
-            <a:off x="1143000" y="5212080"/>
-            <a:ext cx="0" cy="146304"/>
+            <a:off x="8887967" y="2432304"/>
+            <a:ext cx="256032" cy="310896"/>
           </a:xfrm>
-          <a:prstGeom prst="line">
+          <a:prstGeom prst="rightArrow">
             <a:avLst/>
           </a:prstGeom>
-          <a:ln w="19050">
-            <a:solidFill>
-              <a:srgbClr val="1F3864"/>
-            </a:solidFill>
-            <a:tailEnd type="triangle" w="med" len="med"/>
+          <a:solidFill>
+            <a:srgbClr val="1F3864"/>
+          </a:solidFill>
+          <a:ln>
+            <a:noFill/>
           </a:ln>
+          <a:effectLst/>
         </p:spPr>
         <p:style>
-          <a:lnRef idx="2">
+          <a:lnRef idx="1">
             <a:schemeClr val="accent1"/>
           </a:lnRef>
-          <a:fillRef idx="0">
+          <a:fillRef idx="3">
             <a:schemeClr val="accent1"/>
           </a:fillRef>
-          <a:effectRef idx="1">
+          <a:effectRef idx="2">
             <a:schemeClr val="accent1"/>
           </a:effectRef>
           <a:fontRef idx="minor">
-            <a:schemeClr val="tx1"/>
+            <a:schemeClr val="lt1"/>
           </a:fontRef>
         </p:style>
-      </p:cxnSp>
+        <p:txBody>
+          <a:bodyPr rtlCol="0" anchor="ctr"/>
+          <a:lstStyle/>
+          <a:p>
+            <a:pPr algn="ctr"/>
+          </a:p>
+        </p:txBody>
+      </p:sp>
       <p:sp>
         <p:nvSpPr>
           <p:cNvPr id="173" name="Rounded Rectangle 172"/>
@@ -23528,8 +23552,8 @@
         </p:nvSpPr>
         <p:spPr>
           <a:xfrm>
-            <a:off x="2057400" y="5358384"/>
-            <a:ext cx="2517648" cy="841248"/>
+            <a:off x="9171432" y="2916936"/>
+            <a:ext cx="2624328" cy="868679"/>
           </a:xfrm>
           <a:prstGeom prst="roundRect">
             <a:avLst>
@@ -23573,13 +23597,13 @@
               </a:spcAft>
             </a:pPr>
             <a:r>
-              <a:rPr sz="1200" b="1" i="0">
+              <a:rPr sz="1150" b="1" i="0">
                 <a:solidFill>
                   <a:srgbClr val="1F3864"/>
                 </a:solidFill>
                 <a:latin typeface="Calibri"/>
               </a:rPr>
-              <a:t>FastAPI + SQLAlchemy</a:t>
+              <a:t>FastAPI · la API</a:t>
             </a:r>
           </a:p>
           <a:p>
@@ -23592,13 +23616,13 @@
               </a:spcAft>
             </a:pPr>
             <a:r>
-              <a:rPr sz="1000" b="0" i="0">
+              <a:rPr sz="950" b="0" i="0">
                 <a:solidFill>
                   <a:srgbClr val="1C1C1C"/>
                 </a:solidFill>
                 <a:latin typeface="Calibri"/>
               </a:rPr>
-              <a:t>API REST bajo el contrato OpenAPI congelado. No importa la visión: corre sin GPU.</a:t>
+              <a:t>Servicio que entrega los datos a la web bajo un contrato fijo (OpenAPI) acordado antes de programar. Corre sin GPU.</a:t>
             </a:r>
           </a:p>
         </p:txBody>
@@ -23611,8 +23635,8 @@
         </p:nvSpPr>
         <p:spPr>
           <a:xfrm>
-            <a:off x="4684776" y="5358384"/>
-            <a:ext cx="2517648" cy="841248"/>
+            <a:off x="9171432" y="3858768"/>
+            <a:ext cx="2624328" cy="868679"/>
           </a:xfrm>
           <a:prstGeom prst="roundRect">
             <a:avLst>
@@ -23656,13 +23680,13 @@
               </a:spcAft>
             </a:pPr>
             <a:r>
-              <a:rPr sz="1200" b="1" i="0">
+              <a:rPr sz="1150" b="1" i="0">
                 <a:solidFill>
                   <a:srgbClr val="1F3864"/>
                 </a:solidFill>
                 <a:latin typeface="Calibri"/>
               </a:rPr>
-              <a:t>React + Vite + TypeScript</a:t>
+              <a:t>React · la web</a:t>
             </a:r>
           </a:p>
           <a:p>
@@ -23675,13 +23699,13 @@
               </a:spcAft>
             </a:pPr>
             <a:r>
-              <a:rPr sz="1000" b="0" i="0">
+              <a:rPr sz="950" b="0" i="0">
                 <a:solidFill>
                   <a:srgbClr val="1C1C1C"/>
                 </a:solidFill>
                 <a:latin typeface="Calibri"/>
               </a:rPr>
-              <a:t>Bandeja de hallazgos, visor de evidencia, reglas y tablero. Hoy se desarrolla contra el mock de Prism.</a:t>
+              <a:t>Bandeja de hallazgos, visor de evidencia, reglas y tablero. Miguel y Lian la construyen contra un servidor simulado (Prism).</a:t>
             </a:r>
           </a:p>
         </p:txBody>
@@ -23694,8 +23718,8 @@
         </p:nvSpPr>
         <p:spPr>
           <a:xfrm>
-            <a:off x="7312152" y="5358384"/>
-            <a:ext cx="2517648" cy="841248"/>
+            <a:off x="9171432" y="4800600"/>
+            <a:ext cx="2624328" cy="868679"/>
           </a:xfrm>
           <a:prstGeom prst="roundRect">
             <a:avLst>
@@ -23739,13 +23763,13 @@
               </a:spcAft>
             </a:pPr>
             <a:r>
-              <a:rPr sz="1200" b="1" i="0">
+              <a:rPr sz="1150" b="1" i="0">
                 <a:solidFill>
                   <a:srgbClr val="1F3864"/>
                 </a:solidFill>
                 <a:latin typeface="Calibri"/>
               </a:rPr>
-              <a:t>Canal de alerta: Telegram o correo</a:t>
+              <a:t>Telegram o correo · la alerta</a:t>
             </a:r>
           </a:p>
           <a:p>
@@ -23758,13 +23782,13 @@
               </a:spcAft>
             </a:pPr>
             <a:r>
-              <a:rPr sz="1000" b="0" i="0">
+              <a:rPr sz="950" b="0" i="0">
                 <a:solidFill>
                   <a:srgbClr val="1C1C1C"/>
                 </a:solidFill>
                 <a:latin typeface="Calibri"/>
               </a:rPr>
-              <a:t>Patrón outbox con acuse de recibo y supresión: como máximo 6 avisos por turno de 12 h.</a:t>
+              <a:t>Aviso al responsable con acuse de recibo. Máximo 6 avisos por turno para no saturar a nadie.</a:t>
             </a:r>
           </a:p>
         </p:txBody>
@@ -23777,8 +23801,8 @@
         </p:nvSpPr>
         <p:spPr>
           <a:xfrm>
-            <a:off x="10012680" y="2395728"/>
-            <a:ext cx="1783080" cy="3803904"/>
+            <a:off x="365760" y="5760719"/>
+            <a:ext cx="11430000" cy="603504"/>
           </a:xfrm>
           <a:prstGeom prst="roundRect">
             <a:avLst>
@@ -23813,12 +23837,38 @@
           <a:bodyPr rtlCol="0" anchor="t" wrap="square" tIns="54864" bIns="54864"/>
           <a:lstStyle/>
           <a:p>
+            <a:pPr algn="ctr"/>
+          </a:p>
+        </p:txBody>
+      </p:sp>
+      <p:sp>
+        <p:nvSpPr>
+          <p:cNvPr id="177" name="TextBox 176"/>
+          <p:cNvSpPr txBox="1"/>
+          <p:nvPr/>
+        </p:nvSpPr>
+        <p:spPr>
+          <a:xfrm>
+            <a:off x="411480" y="5760719"/>
+            <a:ext cx="1463040" cy="603504"/>
+          </a:xfrm>
+          <a:prstGeom prst="rect">
+            <a:avLst/>
+          </a:prstGeom>
+          <a:noFill/>
+        </p:spPr>
+        <p:txBody>
+          <a:bodyPr wrap="square" anchor="ctr" lIns="73152" rIns="73152" tIns="36576" bIns="36576">
+            <a:spAutoFit/>
+          </a:bodyPr>
+          <a:lstStyle/>
+          <a:p>
             <a:pPr algn="l">
               <a:spcBef>
                 <a:spcPts val="0"/>
               </a:spcBef>
               <a:spcAft>
-                <a:spcPts val="300"/>
+                <a:spcPts val="0"/>
               </a:spcAft>
             </a:pPr>
             <a:r>
@@ -23828,16 +23878,58 @@
                 </a:solidFill>
                 <a:latin typeface="Calibri"/>
               </a:rPr>
-              <a:t>CÓMO SE CONSTRUYE</a:t>
+              <a:t>CÓMO SE</a:t>
             </a:r>
           </a:p>
           <a:p>
+            <a:pPr algn="l">
+              <a:spcBef>
+                <a:spcPts val="0"/>
+              </a:spcBef>
+              <a:spcAft>
+                <a:spcPts val="0"/>
+              </a:spcAft>
+            </a:pPr>
+            <a:r>
+              <a:rPr sz="1100" b="1" i="0">
+                <a:solidFill>
+                  <a:srgbClr val="1F3864"/>
+                </a:solidFill>
+                <a:latin typeface="Calibri"/>
+              </a:rPr>
+              <a:t>CONSTRUYE</a:t>
+            </a:r>
+          </a:p>
+        </p:txBody>
+      </p:sp>
+      <p:sp>
+        <p:nvSpPr>
+          <p:cNvPr id="178" name="TextBox 177"/>
+          <p:cNvSpPr txBox="1"/>
+          <p:nvPr/>
+        </p:nvSpPr>
+        <p:spPr>
+          <a:xfrm>
+            <a:off x="1920240" y="5779007"/>
+            <a:ext cx="3291840" cy="566928"/>
+          </a:xfrm>
+          <a:prstGeom prst="rect">
+            <a:avLst/>
+          </a:prstGeom>
+          <a:noFill/>
+        </p:spPr>
+        <p:txBody>
+          <a:bodyPr wrap="square" anchor="ctr" lIns="73152" rIns="73152" tIns="36576" bIns="36576">
+            <a:spAutoFit/>
+          </a:bodyPr>
+          <a:lstStyle/>
+          <a:p>
             <a:pPr>
               <a:spcBef>
                 <a:spcPts val="0"/>
               </a:spcBef>
               <a:spcAft>
-                <a:spcPts val="300"/>
+                <a:spcPts val="200"/>
               </a:spcAft>
             </a:pPr>
             <a:r>
@@ -23856,7 +23948,7 @@
                 </a:solidFill>
                 <a:latin typeface="Calibri"/>
               </a:rPr>
-              <a:t> · monorepo Python con un solo lockfile; instalación con o sin GPU</a:t>
+              <a:t> · un solo entorno Python para todos los módulos</a:t>
             </a:r>
           </a:p>
           <a:p>
@@ -23865,7 +23957,7 @@
                 <a:spcPts val="0"/>
               </a:spcBef>
               <a:spcAft>
-                <a:spcPts val="300"/>
+                <a:spcPts val="200"/>
               </a:spcAft>
             </a:pPr>
             <a:r>
@@ -23884,16 +23976,39 @@
                 </a:solidFill>
                 <a:latin typeface="Calibri"/>
               </a:rPr>
-              <a:t> · pruebas, tipado estricto y estilo en cada empuje</a:t>
+              <a:t> · pruebas, tipos y estilo automáticos</a:t>
             </a:r>
           </a:p>
+        </p:txBody>
+      </p:sp>
+      <p:sp>
+        <p:nvSpPr>
+          <p:cNvPr id="179" name="TextBox 178"/>
+          <p:cNvSpPr txBox="1"/>
+          <p:nvPr/>
+        </p:nvSpPr>
+        <p:spPr>
+          <a:xfrm>
+            <a:off x="5212080" y="5779007"/>
+            <a:ext cx="3291840" cy="566928"/>
+          </a:xfrm>
+          <a:prstGeom prst="rect">
+            <a:avLst/>
+          </a:prstGeom>
+          <a:noFill/>
+        </p:spPr>
+        <p:txBody>
+          <a:bodyPr wrap="square" anchor="ctr" lIns="73152" rIns="73152" tIns="36576" bIns="36576">
+            <a:spAutoFit/>
+          </a:bodyPr>
+          <a:lstStyle/>
           <a:p>
             <a:pPr>
               <a:spcBef>
                 <a:spcPts val="0"/>
               </a:spcBef>
               <a:spcAft>
-                <a:spcPts val="300"/>
+                <a:spcPts val="200"/>
               </a:spcAft>
             </a:pPr>
             <a:r>
@@ -23912,7 +24027,7 @@
                 </a:solidFill>
                 <a:latin typeface="Calibri"/>
               </a:rPr>
-              <a:t> · CI en dos versiones de Python; falla si entra una licencia AGPL</a:t>
+              <a:t> · integración continua; bloquea licencias AGPL</a:t>
             </a:r>
           </a:p>
           <a:p>
@@ -23921,7 +24036,7 @@
                 <a:spcPts val="0"/>
               </a:spcBef>
               <a:spcAft>
-                <a:spcPts val="300"/>
+                <a:spcPts val="200"/>
               </a:spcAft>
             </a:pPr>
             <a:r>
@@ -23940,16 +24055,39 @@
                 </a:solidFill>
                 <a:latin typeface="Calibri"/>
               </a:rPr>
-              <a:t> · PostgreSQL, Redis y MediaMTX en un comando</a:t>
+              <a:t> · PostgreSQL y Redis con un comando</a:t>
             </a:r>
           </a:p>
+        </p:txBody>
+      </p:sp>
+      <p:sp>
+        <p:nvSpPr>
+          <p:cNvPr id="180" name="TextBox 179"/>
+          <p:cNvSpPr txBox="1"/>
+          <p:nvPr/>
+        </p:nvSpPr>
+        <p:spPr>
+          <a:xfrm>
+            <a:off x="8503920" y="5779007"/>
+            <a:ext cx="3291840" cy="566928"/>
+          </a:xfrm>
+          <a:prstGeom prst="rect">
+            <a:avLst/>
+          </a:prstGeom>
+          <a:noFill/>
+        </p:spPr>
+        <p:txBody>
+          <a:bodyPr wrap="square" anchor="ctr" lIns="73152" rIns="73152" tIns="36576" bIns="36576">
+            <a:spAutoFit/>
+          </a:bodyPr>
+          <a:lstStyle/>
           <a:p>
             <a:pPr>
               <a:spcBef>
                 <a:spcPts val="0"/>
               </a:spcBef>
               <a:spcAft>
-                <a:spcPts val="300"/>
+                <a:spcPts val="200"/>
               </a:spcAft>
             </a:pPr>
             <a:r>
@@ -23968,7 +24106,7 @@
                 </a:solidFill>
                 <a:latin typeface="Calibri"/>
               </a:rPr>
-              <a:t> · servidor simulado del contrato: el frontend no espera al backend</a:t>
+              <a:t> · servidor simulado: la web avanza sin backend</a:t>
             </a:r>
           </a:p>
           <a:p>
@@ -23977,7 +24115,7 @@
                 <a:spcPts val="0"/>
               </a:spcBef>
               <a:spcAft>
-                <a:spcPts val="300"/>
+                <a:spcPts val="200"/>
               </a:spcAft>
             </a:pPr>
             <a:r>
@@ -23996,21 +24134,21 @@
                 </a:solidFill>
                 <a:latin typeface="Calibri"/>
               </a:rPr>
-              <a:t> · etiquetado autoalojado: ninguna imagen sale de la máquina</a:t>
+              <a:t> · etiquetado de imágenes en nuestro computador</a:t>
             </a:r>
           </a:p>
         </p:txBody>
       </p:sp>
       <p:sp>
         <p:nvSpPr>
-          <p:cNvPr id="177" name="TextBox 176"/>
+          <p:cNvPr id="181" name="TextBox 180"/>
           <p:cNvSpPr txBox="1"/>
           <p:nvPr/>
         </p:nvSpPr>
         <p:spPr>
           <a:xfrm>
-            <a:off x="365760" y="6291072"/>
-            <a:ext cx="11430000" cy="365760"/>
+            <a:off x="365760" y="6409943"/>
+            <a:ext cx="11430000" cy="310896"/>
           </a:xfrm>
           <a:prstGeom prst="rect">
             <a:avLst/>
@@ -24032,13 +24170,13 @@
               </a:spcAft>
             </a:pPr>
             <a:r>
-              <a:rPr sz="1100" b="1" i="0">
+              <a:rPr sz="1050" b="1" i="0">
                 <a:solidFill>
                   <a:srgbClr val="1F3864"/>
                 </a:solidFill>
                 <a:latin typeface="Calibri"/>
               </a:rPr>
-              <a:t>La Etapa 1 (detector + reglas) decide; la Etapa 2 (Qwen3-VL, extensión) solo describe.   ·   El evento es la unidad: un turno son 12 hallazgos, no 200.000 cuadros.</a:t>
+              <a:t>El detector y las reglas deciden; la descripción con IA (extensión futura) solo describe.   ·   La unidad es el evento: un turno son 12 hallazgos, no 200.000 cuadros.</a:t>
             </a:r>
           </a:p>
         </p:txBody>

</xml_diff>

<commit_message>
docs: lámina 8 aclara que visión y web son dos programas unidos por la base
Edgar preguntó cómo se integra la visión con la web: la lámina no lo
decía. Ahora una franja agrupa las etapas 1 a 3 como "A · Procesador de
video" (corre solo en el servidor cada vez que llega un video) y la
etapa 4 como "B · Plataforma web" (lo que se abre en el navegador), cada
etapa lleva un "cuándo", y el pie explica que A y B solo se comunican
por la base de datos. Redis y ONNX Runtime quedan con "qué es" y "para
qué", y "bloquea licencias AGPL" pasa a "rechaza librerías AGPL (como
YOLO), que obligarían a liberar todo el código".

Co-Authored-By: Claude Fable 5.1 <noreply@anthropic.com>
Claude-Session: https://claude.ai/code/session_01Rvh88dkfXqgVzQiFw1YokL
</commit_message>
<xml_diff>
--- a/Fase 1/Evidencias Grupales/Presentación Proyecto.pptx
+++ b/Fase 1/Evidencias Grupales/Presentación Proyecto.pptx
@@ -1419,7 +1419,7 @@
           <a:lstStyle/>
           <a:p>
             <a:r>
-              <a:t>3:00 · Edgar. Leer el flujo de izquierda a derecha, una columna por vez. (1) Entra el video: la obra deja sus grabaciones en una carpeta y el sistema las toma solo; OpenCV lee el video, se queda con 5 cuadros por segundo, tapa las zonas que no se deben analizar y difumina rostros antes de guardar; cada cuadro queda fechado con la hora real de la grabación. (2) Se detecta y se sigue: RF-DETR es el modelo que marca personas, cascos y chalecos, entrenado con nuestras imágenes; es de licencia libre y por eso no usamos YOLO, cuya licencia AGPL alcanza a los modelos entrenados y obligaría a liberar todo el sistema. ByteTrack sigue a cada persona de un cuadro al siguiente con un número temporal: nunca sabemos quién es. ONNX Runtime hace que el modelo, entrenado una vez con GPU, corra en cualquier computador. (3) Se decide y se guarda: el motor de reglas, código propio, convierte recorridos en hallazgos según las reglas de la obra, medidas en segundos; PostgreSQL guarda todo, incluidas las detecciones cuadro a cuadro, y por eso se puede cambiar una regla y recalcular sin reprocesar video; Redis es la fila de espera de los videos. (4) Se usa: FastAPI entrega los datos a la web bajo un contrato acordado antes de programar; React es la web que construyen Miguel y Lian; la alerta llega por Telegram o correo con acuse de recibo y un máximo de seis avisos por turno. Abajo, cómo se construye. Cerrar con la línea final: el detector y las reglas deciden, la descripción con IA solo describe, y la unidad es el evento. Si preguntan por las cámaras en vivo: RTSP es el protocolo de las cámaras IP; la versión 2 se conecta a cámaras en vez de leer archivos y se prueba desde la semana 6 simulando una cámara con un video grabado (MediaMTX).</a:t>
+              <a:t>3:00 · Edgar. Empezar por la franja de arriba: son dos programas. A, el procesador de video, corre solo en el servidor, en segundo plano, cada vez que llega un video; B, la plataforma web, es lo que el usuario abre en el navegador. Se comunican solo por la base de datos: A escribe hallazgos, B los lee. Luego el flujo de izquierda a derecha. (1) Entra el video: la obra deja sus grabaciones en una carpeta y el sistema las toma solo; OpenCV lee el video, se queda con 5 cuadros por segundo, tapa las zonas que no se deben analizar y difumina rostros antes de guardar; cada cuadro queda fechado con la hora real de la grabación. (2) Se detecta y se sigue: RF-DETR es el modelo que marca personas, cascos y chalecos, entrenado con nuestras imágenes; es de licencia libre y por eso no usamos YOLO, cuya licencia AGPL obligaría a liberar todo el código. ByteTrack sigue a cada persona de un cuadro al siguiente con un número temporal: nunca sabemos quién es. ONNX Runtime es el motor que ejecuta el modelo ya entrenado, para que corra en cualquier computador sin tarjeta gráfica. (3) Se decide y se guarda: el motor de reglas, código propio, convierte recorridos en hallazgos según las reglas de la obra, medidas en segundos; PostgreSQL guarda todo, incluidas las detecciones cuadro a cuadro, y por eso se puede cambiar una regla y recalcular sin reprocesar video; Redis es una base de datos en memoria que usamos como fila de espera de los videos. (4) Se usa: FastAPI lee la base y entrega los datos a la web bajo un contrato acordado antes de programar; React es la web que construyen Miguel y Lian; la alerta llega sola al teléfono cuando se guarda un hallazgo grave, con acuse de recibo y un máximo de seis avisos por turno. Abajo, cómo se construye; la integración continua rechaza librerías AGPL. Cerrar con la última línea: el detector y las reglas deciden, la descripción con IA solo describe, y la unidad es el evento. Si preguntan por cámaras en vivo: RTSP es el protocolo de las cámaras IP; la versión 2 se conecta a cámaras en vez de leer archivos y se prueba desde la semana 6 simulando una cámara con un video grabado (MediaMTX).</a:t>
             </a:r>
           </a:p>
         </p:txBody>
@@ -22424,7 +22424,153 @@
         </p:nvSpPr>
         <p:spPr>
           <a:xfrm>
-            <a:off x="365760" y="2331720"/>
+            <a:off x="365760" y="2304288"/>
+            <a:ext cx="8494776" cy="274320"/>
+          </a:xfrm>
+          <a:prstGeom prst="roundRect">
+            <a:avLst>
+              <a:gd name="adj" fmla="val 8000"/>
+            </a:avLst>
+          </a:prstGeom>
+          <a:solidFill>
+            <a:srgbClr val="DDE5F0"/>
+          </a:solidFill>
+          <a:ln w="12700">
+            <a:solidFill>
+              <a:srgbClr val="1F3864"/>
+            </a:solidFill>
+          </a:ln>
+          <a:effectLst/>
+        </p:spPr>
+        <p:style>
+          <a:lnRef idx="1">
+            <a:schemeClr val="accent1"/>
+          </a:lnRef>
+          <a:fillRef idx="3">
+            <a:schemeClr val="accent1"/>
+          </a:fillRef>
+          <a:effectRef idx="2">
+            <a:schemeClr val="accent1"/>
+          </a:effectRef>
+          <a:fontRef idx="minor">
+            <a:schemeClr val="lt1"/>
+          </a:fontRef>
+        </p:style>
+        <p:txBody>
+          <a:bodyPr rtlCol="0" anchor="ctr" wrap="square" tIns="54864" bIns="54864"/>
+          <a:lstStyle/>
+          <a:p>
+            <a:pPr algn="l">
+              <a:spcBef>
+                <a:spcPts val="0"/>
+              </a:spcBef>
+              <a:spcAft>
+                <a:spcPts val="0"/>
+              </a:spcAft>
+            </a:pPr>
+            <a:r>
+              <a:rPr sz="950" b="1">
+                <a:solidFill>
+                  <a:srgbClr val="1F3864"/>
+                </a:solidFill>
+                <a:latin typeface="Calibri"/>
+              </a:rPr>
+              <a:t>A · PROCESADOR DE VIDEO</a:t>
+            </a:r>
+            <a:r>
+              <a:rPr sz="950" b="0">
+                <a:solidFill>
+                  <a:srgbClr val="1C1C1C"/>
+                </a:solidFill>
+                <a:latin typeface="Calibri"/>
+              </a:rPr>
+              <a:t>  ·  un programa que corre solo en el servidor cada vez que llega un video  ·  módulos propios: gepp-worker, gepp-vision, gepp-core</a:t>
+            </a:r>
+          </a:p>
+        </p:txBody>
+      </p:sp>
+      <p:sp>
+        <p:nvSpPr>
+          <p:cNvPr id="159" name="Rounded Rectangle 158"/>
+          <p:cNvSpPr/>
+          <p:nvPr/>
+        </p:nvSpPr>
+        <p:spPr>
+          <a:xfrm>
+            <a:off x="9171432" y="2304288"/>
+            <a:ext cx="2624328" cy="274320"/>
+          </a:xfrm>
+          <a:prstGeom prst="roundRect">
+            <a:avLst>
+              <a:gd name="adj" fmla="val 8000"/>
+            </a:avLst>
+          </a:prstGeom>
+          <a:solidFill>
+            <a:srgbClr val="DDE5F0"/>
+          </a:solidFill>
+          <a:ln w="12700">
+            <a:solidFill>
+              <a:srgbClr val="1F3864"/>
+            </a:solidFill>
+          </a:ln>
+          <a:effectLst/>
+        </p:spPr>
+        <p:style>
+          <a:lnRef idx="1">
+            <a:schemeClr val="accent1"/>
+          </a:lnRef>
+          <a:fillRef idx="3">
+            <a:schemeClr val="accent1"/>
+          </a:fillRef>
+          <a:effectRef idx="2">
+            <a:schemeClr val="accent1"/>
+          </a:effectRef>
+          <a:fontRef idx="minor">
+            <a:schemeClr val="lt1"/>
+          </a:fontRef>
+        </p:style>
+        <p:txBody>
+          <a:bodyPr rtlCol="0" anchor="ctr" wrap="square" tIns="54864" bIns="54864"/>
+          <a:lstStyle/>
+          <a:p>
+            <a:pPr algn="l">
+              <a:spcBef>
+                <a:spcPts val="0"/>
+              </a:spcBef>
+              <a:spcAft>
+                <a:spcPts val="0"/>
+              </a:spcAft>
+            </a:pPr>
+            <a:r>
+              <a:rPr sz="950" b="1">
+                <a:solidFill>
+                  <a:srgbClr val="1F3864"/>
+                </a:solidFill>
+                <a:latin typeface="Calibri"/>
+              </a:rPr>
+              <a:t>B · PLATAFORMA WEB</a:t>
+            </a:r>
+            <a:r>
+              <a:rPr sz="950" b="0">
+                <a:solidFill>
+                  <a:srgbClr val="1C1C1C"/>
+                </a:solidFill>
+                <a:latin typeface="Calibri"/>
+              </a:rPr>
+              <a:t>  ·  gepp-api y la web</a:t>
+            </a:r>
+          </a:p>
+        </p:txBody>
+      </p:sp>
+      <p:sp>
+        <p:nvSpPr>
+          <p:cNvPr id="160" name="Rounded Rectangle 159"/>
+          <p:cNvSpPr/>
+          <p:nvPr/>
+        </p:nvSpPr>
+        <p:spPr>
+          <a:xfrm>
+            <a:off x="365760" y="2633472"/>
             <a:ext cx="2624328" cy="512064"/>
           </a:xfrm>
           <a:prstGeom prst="roundRect">
@@ -22494,21 +22640,21 @@
                 </a:solidFill>
                 <a:latin typeface="Calibri"/>
               </a:rPr>
-              <a:t>código propio: gepp-worker</a:t>
+              <a:t>cuándo: cada vez que llega un video</a:t>
             </a:r>
           </a:p>
         </p:txBody>
       </p:sp>
       <p:sp>
         <p:nvSpPr>
-          <p:cNvPr id="159" name="Rounded Rectangle 158"/>
+          <p:cNvPr id="161" name="Rounded Rectangle 160"/>
           <p:cNvSpPr/>
           <p:nvPr/>
         </p:nvSpPr>
         <p:spPr>
           <a:xfrm>
-            <a:off x="365760" y="2916936"/>
-            <a:ext cx="2624328" cy="1339595"/>
+            <a:off x="365760" y="3218688"/>
+            <a:ext cx="2624328" cy="1243584"/>
           </a:xfrm>
           <a:prstGeom prst="roundRect">
             <a:avLst>
@@ -22584,14 +22730,14 @@
       </p:sp>
       <p:sp>
         <p:nvSpPr>
-          <p:cNvPr id="160" name="Rounded Rectangle 159"/>
+          <p:cNvPr id="162" name="Rounded Rectangle 161"/>
           <p:cNvSpPr/>
           <p:nvPr/>
         </p:nvSpPr>
         <p:spPr>
           <a:xfrm>
-            <a:off x="365760" y="4329683"/>
-            <a:ext cx="2624328" cy="1339595"/>
+            <a:off x="365760" y="4535424"/>
+            <a:ext cx="2624328" cy="1243584"/>
           </a:xfrm>
           <a:prstGeom prst="roundRect">
             <a:avLst>
@@ -22667,13 +22813,13 @@
       </p:sp>
       <p:sp>
         <p:nvSpPr>
-          <p:cNvPr id="161" name="Rounded Rectangle 160"/>
+          <p:cNvPr id="163" name="Rounded Rectangle 162"/>
           <p:cNvSpPr/>
           <p:nvPr/>
         </p:nvSpPr>
         <p:spPr>
           <a:xfrm>
-            <a:off x="3300984" y="2331720"/>
+            <a:off x="3300984" y="2633472"/>
             <a:ext cx="2624328" cy="512064"/>
           </a:xfrm>
           <a:prstGeom prst="roundRect">
@@ -22743,20 +22889,20 @@
                 </a:solidFill>
                 <a:latin typeface="Calibri"/>
               </a:rPr>
-              <a:t>código propio: gepp-vision</a:t>
+              <a:t>cuándo: enseguida, sin que nadie lo pida</a:t>
             </a:r>
           </a:p>
         </p:txBody>
       </p:sp>
       <p:sp>
         <p:nvSpPr>
-          <p:cNvPr id="162" name="Right Arrow 161"/>
+          <p:cNvPr id="164" name="Right Arrow 163"/>
           <p:cNvSpPr/>
           <p:nvPr/>
         </p:nvSpPr>
         <p:spPr>
           <a:xfrm>
-            <a:off x="3017520" y="2432304"/>
+            <a:off x="3017520" y="2734056"/>
             <a:ext cx="256032" cy="310896"/>
           </a:xfrm>
           <a:prstGeom prst="rightArrow">
@@ -22794,14 +22940,14 @@
       </p:sp>
       <p:sp>
         <p:nvSpPr>
-          <p:cNvPr id="163" name="Rounded Rectangle 162"/>
+          <p:cNvPr id="165" name="Rounded Rectangle 164"/>
           <p:cNvSpPr/>
           <p:nvPr/>
         </p:nvSpPr>
         <p:spPr>
           <a:xfrm>
-            <a:off x="3300984" y="2916936"/>
-            <a:ext cx="2624328" cy="868679"/>
+            <a:off x="3300984" y="3218688"/>
+            <a:ext cx="2624328" cy="804672"/>
           </a:xfrm>
           <a:prstGeom prst="roundRect">
             <a:avLst>
@@ -22877,14 +23023,14 @@
       </p:sp>
       <p:sp>
         <p:nvSpPr>
-          <p:cNvPr id="164" name="Rounded Rectangle 163"/>
+          <p:cNvPr id="166" name="Rounded Rectangle 165"/>
           <p:cNvSpPr/>
           <p:nvPr/>
         </p:nvSpPr>
         <p:spPr>
           <a:xfrm>
-            <a:off x="3300984" y="3858768"/>
-            <a:ext cx="2624328" cy="868679"/>
+            <a:off x="3300984" y="4096512"/>
+            <a:ext cx="2624328" cy="804672"/>
           </a:xfrm>
           <a:prstGeom prst="roundRect">
             <a:avLst>
@@ -22960,14 +23106,14 @@
       </p:sp>
       <p:sp>
         <p:nvSpPr>
-          <p:cNvPr id="165" name="Rounded Rectangle 164"/>
+          <p:cNvPr id="167" name="Rounded Rectangle 166"/>
           <p:cNvSpPr/>
           <p:nvPr/>
         </p:nvSpPr>
         <p:spPr>
           <a:xfrm>
-            <a:off x="3300984" y="4800600"/>
-            <a:ext cx="2624328" cy="868679"/>
+            <a:off x="3300984" y="4974336"/>
+            <a:ext cx="2624328" cy="804672"/>
           </a:xfrm>
           <a:prstGeom prst="roundRect">
             <a:avLst>
@@ -23036,20 +23182,20 @@
                 </a:solidFill>
                 <a:latin typeface="Calibri"/>
               </a:rPr>
-              <a:t>El modelo se entrena una vez con tarjeta gráfica (GPU) y después corre en cualquier computador normal, sin GPU.</a:t>
+              <a:t>Qué es: motor que ejecuta modelos ya entrenados. Para qué: que el modelo corra en cualquier computador, sin tarjeta gráfica.</a:t>
             </a:r>
           </a:p>
         </p:txBody>
       </p:sp>
       <p:sp>
         <p:nvSpPr>
-          <p:cNvPr id="166" name="Rounded Rectangle 165"/>
+          <p:cNvPr id="168" name="Rounded Rectangle 167"/>
           <p:cNvSpPr/>
           <p:nvPr/>
         </p:nvSpPr>
         <p:spPr>
           <a:xfrm>
-            <a:off x="6236208" y="2331720"/>
+            <a:off x="6236208" y="2633472"/>
             <a:ext cx="2624328" cy="512064"/>
           </a:xfrm>
           <a:prstGeom prst="roundRect">
@@ -23119,20 +23265,20 @@
                 </a:solidFill>
                 <a:latin typeface="Calibri"/>
               </a:rPr>
-              <a:t>código propio: gepp-core</a:t>
+              <a:t>cuándo: al terminar cada video</a:t>
             </a:r>
           </a:p>
         </p:txBody>
       </p:sp>
       <p:sp>
         <p:nvSpPr>
-          <p:cNvPr id="167" name="Right Arrow 166"/>
+          <p:cNvPr id="169" name="Right Arrow 168"/>
           <p:cNvSpPr/>
           <p:nvPr/>
         </p:nvSpPr>
         <p:spPr>
           <a:xfrm>
-            <a:off x="5952744" y="2432304"/>
+            <a:off x="5952744" y="2734056"/>
             <a:ext cx="256032" cy="310896"/>
           </a:xfrm>
           <a:prstGeom prst="rightArrow">
@@ -23170,14 +23316,14 @@
       </p:sp>
       <p:sp>
         <p:nvSpPr>
-          <p:cNvPr id="168" name="Rounded Rectangle 167"/>
+          <p:cNvPr id="170" name="Rounded Rectangle 169"/>
           <p:cNvSpPr/>
           <p:nvPr/>
         </p:nvSpPr>
         <p:spPr>
           <a:xfrm>
-            <a:off x="6236208" y="2916936"/>
-            <a:ext cx="2624328" cy="868679"/>
+            <a:off x="6236208" y="3218688"/>
+            <a:ext cx="2624328" cy="804672"/>
           </a:xfrm>
           <a:prstGeom prst="roundRect">
             <a:avLst>
@@ -23253,14 +23399,14 @@
       </p:sp>
       <p:sp>
         <p:nvSpPr>
-          <p:cNvPr id="169" name="Rounded Rectangle 168"/>
+          <p:cNvPr id="171" name="Rounded Rectangle 170"/>
           <p:cNvSpPr/>
           <p:nvPr/>
         </p:nvSpPr>
         <p:spPr>
           <a:xfrm>
-            <a:off x="6236208" y="3858768"/>
-            <a:ext cx="2624328" cy="868679"/>
+            <a:off x="6236208" y="4096512"/>
+            <a:ext cx="2624328" cy="804672"/>
           </a:xfrm>
           <a:prstGeom prst="roundRect">
             <a:avLst>
@@ -23329,21 +23475,21 @@
                 </a:solidFill>
                 <a:latin typeface="Calibri"/>
               </a:rPr>
-              <a:t>Guarda hallazgos, detecciones cuadro a cuadro, reglas con historial y acuses. Así se recalculan reglas sin reprocesar video.</a:t>
+              <a:t>Guarda hallazgos, detecciones cuadro a cuadro, reglas con historial y acuses. Es el punto de encuentro entre A y B.</a:t>
             </a:r>
           </a:p>
         </p:txBody>
       </p:sp>
       <p:sp>
         <p:nvSpPr>
-          <p:cNvPr id="170" name="Rounded Rectangle 169"/>
+          <p:cNvPr id="172" name="Rounded Rectangle 171"/>
           <p:cNvSpPr/>
           <p:nvPr/>
         </p:nvSpPr>
         <p:spPr>
           <a:xfrm>
-            <a:off x="6236208" y="4800600"/>
-            <a:ext cx="2624328" cy="868679"/>
+            <a:off x="6236208" y="4974336"/>
+            <a:ext cx="2624328" cy="804672"/>
           </a:xfrm>
           <a:prstGeom prst="roundRect">
             <a:avLst>
@@ -23412,20 +23558,20 @@
                 </a:solidFill>
                 <a:latin typeface="Calibri"/>
               </a:rPr>
-              <a:t>Fila de espera en memoria: los videos que llegan esperan su turno y se procesan uno a uno, sin bloquear ni perder nada.</a:t>
+              <a:t>Qué es: base de datos en memoria, muy rápida. Para qué: que los videos hagan fila y se procesen de a uno, sin perderse.</a:t>
             </a:r>
           </a:p>
         </p:txBody>
       </p:sp>
       <p:sp>
         <p:nvSpPr>
-          <p:cNvPr id="171" name="Rounded Rectangle 170"/>
+          <p:cNvPr id="173" name="Rounded Rectangle 172"/>
           <p:cNvSpPr/>
           <p:nvPr/>
         </p:nvSpPr>
         <p:spPr>
           <a:xfrm>
-            <a:off x="9171432" y="2331720"/>
+            <a:off x="9171432" y="2633472"/>
             <a:ext cx="2624328" cy="512064"/>
           </a:xfrm>
           <a:prstGeom prst="roundRect">
@@ -23495,20 +23641,20 @@
                 </a:solidFill>
                 <a:latin typeface="Calibri"/>
               </a:rPr>
-              <a:t>código propio: gepp-api · web</a:t>
+              <a:t>cuándo: cuando el usuario abre el navegador</a:t>
             </a:r>
           </a:p>
         </p:txBody>
       </p:sp>
       <p:sp>
         <p:nvSpPr>
-          <p:cNvPr id="172" name="Right Arrow 171"/>
+          <p:cNvPr id="174" name="Right Arrow 173"/>
           <p:cNvSpPr/>
           <p:nvPr/>
         </p:nvSpPr>
         <p:spPr>
           <a:xfrm>
-            <a:off x="8887967" y="2432304"/>
+            <a:off x="8887967" y="2734056"/>
             <a:ext cx="256032" cy="310896"/>
           </a:xfrm>
           <a:prstGeom prst="rightArrow">
@@ -23546,14 +23692,14 @@
       </p:sp>
       <p:sp>
         <p:nvSpPr>
-          <p:cNvPr id="173" name="Rounded Rectangle 172"/>
+          <p:cNvPr id="175" name="Rounded Rectangle 174"/>
           <p:cNvSpPr/>
           <p:nvPr/>
         </p:nvSpPr>
         <p:spPr>
           <a:xfrm>
-            <a:off x="9171432" y="2916936"/>
-            <a:ext cx="2624328" cy="868679"/>
+            <a:off x="9171432" y="3218688"/>
+            <a:ext cx="2624328" cy="804672"/>
           </a:xfrm>
           <a:prstGeom prst="roundRect">
             <a:avLst>
@@ -23622,21 +23768,21 @@
                 </a:solidFill>
                 <a:latin typeface="Calibri"/>
               </a:rPr>
-              <a:t>Servicio que entrega los datos a la web bajo un contrato fijo (OpenAPI) acordado antes de programar. Corre sin GPU.</a:t>
+              <a:t>Servicio que lee la base de datos y entrega la información a la web bajo un contrato fijo (OpenAPI). Corre sin GPU.</a:t>
             </a:r>
           </a:p>
         </p:txBody>
       </p:sp>
       <p:sp>
         <p:nvSpPr>
-          <p:cNvPr id="174" name="Rounded Rectangle 173"/>
+          <p:cNvPr id="176" name="Rounded Rectangle 175"/>
           <p:cNvSpPr/>
           <p:nvPr/>
         </p:nvSpPr>
         <p:spPr>
           <a:xfrm>
-            <a:off x="9171432" y="3858768"/>
-            <a:ext cx="2624328" cy="868679"/>
+            <a:off x="9171432" y="4096512"/>
+            <a:ext cx="2624328" cy="804672"/>
           </a:xfrm>
           <a:prstGeom prst="roundRect">
             <a:avLst>
@@ -23712,14 +23858,14 @@
       </p:sp>
       <p:sp>
         <p:nvSpPr>
-          <p:cNvPr id="175" name="Rounded Rectangle 174"/>
+          <p:cNvPr id="177" name="Rounded Rectangle 176"/>
           <p:cNvSpPr/>
           <p:nvPr/>
         </p:nvSpPr>
         <p:spPr>
           <a:xfrm>
-            <a:off x="9171432" y="4800600"/>
-            <a:ext cx="2624328" cy="868679"/>
+            <a:off x="9171432" y="4974336"/>
+            <a:ext cx="2624328" cy="804672"/>
           </a:xfrm>
           <a:prstGeom prst="roundRect">
             <a:avLst>
@@ -23788,21 +23934,21 @@
                 </a:solidFill>
                 <a:latin typeface="Calibri"/>
               </a:rPr>
-              <a:t>Aviso al responsable con acuse de recibo. Máximo 6 avisos por turno para no saturar a nadie.</a:t>
+              <a:t>Llega sola al teléfono cuando se guarda un hallazgo grave. Acuse de recibo y máximo 6 avisos por turno.</a:t>
             </a:r>
           </a:p>
         </p:txBody>
       </p:sp>
       <p:sp>
         <p:nvSpPr>
-          <p:cNvPr id="176" name="Rounded Rectangle 175"/>
+          <p:cNvPr id="178" name="Rounded Rectangle 177"/>
           <p:cNvSpPr/>
           <p:nvPr/>
         </p:nvSpPr>
         <p:spPr>
           <a:xfrm>
-            <a:off x="365760" y="5760719"/>
-            <a:ext cx="11430000" cy="603504"/>
+            <a:off x="365760" y="5852160"/>
+            <a:ext cx="11430000" cy="512064"/>
           </a:xfrm>
           <a:prstGeom prst="roundRect">
             <a:avLst>
@@ -23843,14 +23989,14 @@
       </p:sp>
       <p:sp>
         <p:nvSpPr>
-          <p:cNvPr id="177" name="TextBox 176"/>
+          <p:cNvPr id="179" name="TextBox 178"/>
           <p:cNvSpPr txBox="1"/>
           <p:nvPr/>
         </p:nvSpPr>
         <p:spPr>
           <a:xfrm>
-            <a:off x="411480" y="5760719"/>
-            <a:ext cx="1463040" cy="603504"/>
+            <a:off x="411480" y="5852160"/>
+            <a:ext cx="1463040" cy="512064"/>
           </a:xfrm>
           <a:prstGeom prst="rect">
             <a:avLst/>
@@ -23904,14 +24050,14 @@
       </p:sp>
       <p:sp>
         <p:nvSpPr>
-          <p:cNvPr id="178" name="TextBox 177"/>
+          <p:cNvPr id="180" name="TextBox 179"/>
           <p:cNvSpPr txBox="1"/>
           <p:nvPr/>
         </p:nvSpPr>
         <p:spPr>
           <a:xfrm>
-            <a:off x="1920240" y="5779007"/>
-            <a:ext cx="3291840" cy="566928"/>
+            <a:off x="1920240" y="5870448"/>
+            <a:ext cx="3291840" cy="475488"/>
           </a:xfrm>
           <a:prstGeom prst="rect">
             <a:avLst/>
@@ -23924,16 +24070,16 @@
           </a:bodyPr>
           <a:lstStyle/>
           <a:p>
-            <a:pPr>
-              <a:spcBef>
-                <a:spcPts val="0"/>
-              </a:spcBef>
-              <a:spcAft>
-                <a:spcPts val="200"/>
+            <a:pPr algn="l">
+              <a:spcBef>
+                <a:spcPts val="0"/>
+              </a:spcBef>
+              <a:spcAft>
+                <a:spcPts val="100"/>
               </a:spcAft>
             </a:pPr>
             <a:r>
-              <a:rPr sz="950" b="1">
+              <a:rPr sz="900" b="1">
                 <a:solidFill>
                   <a:srgbClr val="1F3864"/>
                 </a:solidFill>
@@ -23942,7 +24088,7 @@
               <a:t>uv</a:t>
             </a:r>
             <a:r>
-              <a:rPr sz="950" b="0">
+              <a:rPr sz="900" b="0">
                 <a:solidFill>
                   <a:srgbClr val="1C1C1C"/>
                 </a:solidFill>
@@ -23952,16 +24098,16 @@
             </a:r>
           </a:p>
           <a:p>
-            <a:pPr>
-              <a:spcBef>
-                <a:spcPts val="0"/>
-              </a:spcBef>
-              <a:spcAft>
-                <a:spcPts val="200"/>
+            <a:pPr algn="l">
+              <a:spcBef>
+                <a:spcPts val="0"/>
+              </a:spcBef>
+              <a:spcAft>
+                <a:spcPts val="100"/>
               </a:spcAft>
             </a:pPr>
             <a:r>
-              <a:rPr sz="950" b="1">
+              <a:rPr sz="900" b="1">
                 <a:solidFill>
                   <a:srgbClr val="1F3864"/>
                 </a:solidFill>
@@ -23970,7 +24116,7 @@
               <a:t>pytest · mypy · ruff</a:t>
             </a:r>
             <a:r>
-              <a:rPr sz="950" b="0">
+              <a:rPr sz="900" b="0">
                 <a:solidFill>
                   <a:srgbClr val="1C1C1C"/>
                 </a:solidFill>
@@ -23983,14 +24129,14 @@
       </p:sp>
       <p:sp>
         <p:nvSpPr>
-          <p:cNvPr id="179" name="TextBox 178"/>
+          <p:cNvPr id="181" name="TextBox 180"/>
           <p:cNvSpPr txBox="1"/>
           <p:nvPr/>
         </p:nvSpPr>
         <p:spPr>
           <a:xfrm>
-            <a:off x="5212080" y="5779007"/>
-            <a:ext cx="3291840" cy="566928"/>
+            <a:off x="5212080" y="5870448"/>
+            <a:ext cx="3291840" cy="475488"/>
           </a:xfrm>
           <a:prstGeom prst="rect">
             <a:avLst/>
@@ -24003,16 +24149,16 @@
           </a:bodyPr>
           <a:lstStyle/>
           <a:p>
-            <a:pPr>
-              <a:spcBef>
-                <a:spcPts val="0"/>
-              </a:spcBef>
-              <a:spcAft>
-                <a:spcPts val="200"/>
+            <a:pPr algn="l">
+              <a:spcBef>
+                <a:spcPts val="0"/>
+              </a:spcBef>
+              <a:spcAft>
+                <a:spcPts val="100"/>
               </a:spcAft>
             </a:pPr>
             <a:r>
-              <a:rPr sz="950" b="1">
+              <a:rPr sz="900" b="1">
                 <a:solidFill>
                   <a:srgbClr val="1F3864"/>
                 </a:solidFill>
@@ -24021,26 +24167,26 @@
               <a:t>GitHub Actions</a:t>
             </a:r>
             <a:r>
-              <a:rPr sz="950" b="0">
+              <a:rPr sz="900" b="0">
                 <a:solidFill>
                   <a:srgbClr val="1C1C1C"/>
                 </a:solidFill>
                 <a:latin typeface="Calibri"/>
               </a:rPr>
-              <a:t> · integración continua; bloquea licencias AGPL</a:t>
+              <a:t> · prueba cada cambio; rechaza librerías AGPL (como YOLO), que obligarían a liberar todo el código</a:t>
             </a:r>
           </a:p>
           <a:p>
-            <a:pPr>
-              <a:spcBef>
-                <a:spcPts val="0"/>
-              </a:spcBef>
-              <a:spcAft>
-                <a:spcPts val="200"/>
+            <a:pPr algn="l">
+              <a:spcBef>
+                <a:spcPts val="0"/>
+              </a:spcBef>
+              <a:spcAft>
+                <a:spcPts val="100"/>
               </a:spcAft>
             </a:pPr>
             <a:r>
-              <a:rPr sz="950" b="1">
+              <a:rPr sz="900" b="1">
                 <a:solidFill>
                   <a:srgbClr val="1F3864"/>
                 </a:solidFill>
@@ -24049,7 +24195,7 @@
               <a:t>Docker Compose</a:t>
             </a:r>
             <a:r>
-              <a:rPr sz="950" b="0">
+              <a:rPr sz="900" b="0">
                 <a:solidFill>
                   <a:srgbClr val="1C1C1C"/>
                 </a:solidFill>
@@ -24062,14 +24208,14 @@
       </p:sp>
       <p:sp>
         <p:nvSpPr>
-          <p:cNvPr id="180" name="TextBox 179"/>
+          <p:cNvPr id="182" name="TextBox 181"/>
           <p:cNvSpPr txBox="1"/>
           <p:nvPr/>
         </p:nvSpPr>
         <p:spPr>
           <a:xfrm>
-            <a:off x="8503920" y="5779007"/>
-            <a:ext cx="3291840" cy="566928"/>
+            <a:off x="8503920" y="5870448"/>
+            <a:ext cx="3291840" cy="475488"/>
           </a:xfrm>
           <a:prstGeom prst="rect">
             <a:avLst/>
@@ -24082,16 +24228,16 @@
           </a:bodyPr>
           <a:lstStyle/>
           <a:p>
-            <a:pPr>
-              <a:spcBef>
-                <a:spcPts val="0"/>
-              </a:spcBef>
-              <a:spcAft>
-                <a:spcPts val="200"/>
+            <a:pPr algn="l">
+              <a:spcBef>
+                <a:spcPts val="0"/>
+              </a:spcBef>
+              <a:spcAft>
+                <a:spcPts val="100"/>
               </a:spcAft>
             </a:pPr>
             <a:r>
-              <a:rPr sz="950" b="1">
+              <a:rPr sz="900" b="1">
                 <a:solidFill>
                   <a:srgbClr val="1F3864"/>
                 </a:solidFill>
@@ -24100,7 +24246,7 @@
               <a:t>Prism</a:t>
             </a:r>
             <a:r>
-              <a:rPr sz="950" b="0">
+              <a:rPr sz="900" b="0">
                 <a:solidFill>
                   <a:srgbClr val="1C1C1C"/>
                 </a:solidFill>
@@ -24110,16 +24256,16 @@
             </a:r>
           </a:p>
           <a:p>
-            <a:pPr>
-              <a:spcBef>
-                <a:spcPts val="0"/>
-              </a:spcBef>
-              <a:spcAft>
-                <a:spcPts val="200"/>
+            <a:pPr algn="l">
+              <a:spcBef>
+                <a:spcPts val="0"/>
+              </a:spcBef>
+              <a:spcAft>
+                <a:spcPts val="100"/>
               </a:spcAft>
             </a:pPr>
             <a:r>
-              <a:rPr sz="950" b="1">
+              <a:rPr sz="900" b="1">
                 <a:solidFill>
                   <a:srgbClr val="1F3864"/>
                 </a:solidFill>
@@ -24128,7 +24274,7 @@
               <a:t>CVAT</a:t>
             </a:r>
             <a:r>
-              <a:rPr sz="950" b="0">
+              <a:rPr sz="900" b="0">
                 <a:solidFill>
                   <a:srgbClr val="1C1C1C"/>
                 </a:solidFill>
@@ -24141,14 +24287,14 @@
       </p:sp>
       <p:sp>
         <p:nvSpPr>
-          <p:cNvPr id="181" name="TextBox 180"/>
+          <p:cNvPr id="183" name="TextBox 182"/>
           <p:cNvSpPr txBox="1"/>
           <p:nvPr/>
         </p:nvSpPr>
         <p:spPr>
           <a:xfrm>
-            <a:off x="365760" y="6409943"/>
-            <a:ext cx="11430000" cy="310896"/>
+            <a:off x="365760" y="6400800"/>
+            <a:ext cx="11430000" cy="457200"/>
           </a:xfrm>
           <a:prstGeom prst="rect">
             <a:avLst/>
@@ -24166,11 +24312,30 @@
                 <a:spcPts val="0"/>
               </a:spcBef>
               <a:spcAft>
-                <a:spcPts val="0"/>
+                <a:spcPts val="200"/>
               </a:spcAft>
             </a:pPr>
             <a:r>
-              <a:rPr sz="1050" b="1" i="0">
+              <a:rPr sz="1000" b="0" i="0">
+                <a:solidFill>
+                  <a:srgbClr val="1C1C1C"/>
+                </a:solidFill>
+                <a:latin typeface="Calibri"/>
+              </a:rPr>
+              <a:t>A y B son programas separados que solo se comunican por la base de datos: A escribe los hallazgos, B los lee y los muestra. A trabaja siempre, sin que nadie lo abra; B se usa cuando se necesita.</a:t>
+            </a:r>
+          </a:p>
+          <a:p>
+            <a:pPr algn="ctr">
+              <a:spcBef>
+                <a:spcPts val="0"/>
+              </a:spcBef>
+              <a:spcAft>
+                <a:spcPts val="0"/>
+              </a:spcAft>
+            </a:pPr>
+            <a:r>
+              <a:rPr sz="1000" b="1" i="0">
                 <a:solidFill>
                   <a:srgbClr val="1F3864"/>
                 </a:solidFill>

</xml_diff>

<commit_message>
docs: presentación de la Fase 1 con la lámina de arquitectura nueva, en PDF y PowerPoint
La lámina 8 no se entendía: mezclaba conceptos y restricciones. Ahora
son cuatro etapas de izquierda a derecha, cada tecnología con una frase
sin jerga, y una franja que aclara que el procesador de video y la
plataforma web son dos programas unidos por la base de datos.

Se añade el PDF junto al .pptx porque GitHub lo muestra en el navegador
y el archivo de PowerPoint solo se puede descargar.

Co-Authored-By: Claude Opus 5 (1M context) <noreply@anthropic.com>
Claude-Session: https://claude.ai/code/session_01Rvh88dkfXqgVzQiFw1YokL
</commit_message>
<xml_diff>
--- a/Fase 1/Evidencias Grupales/Presentación Proyecto.pptx
+++ b/Fase 1/Evidencias Grupales/Presentación Proyecto.pptx
@@ -1419,7 +1419,7 @@
           <a:lstStyle/>
           <a:p>
             <a:r>
-              <a:t>3:00 · Edgar. Recorrer el dibujo de arriba abajo: el video entra por un puerto y el reloj nace en la captura; la Etapa 1 muestrea, detecta, sigue y persiste las detecciones crudas; el motor de reglas decide en segundos y produce un hallazgo; el hallazgo alimenta la evidencia, la notificación, la API y la web. La Etapa 2 (modelo de lenguaje visual) solo describe, nunca crea ni suprime hallazgos: así el sistema es auditable. Cerrar con las tres decisiones que hacen que esto no sea un trabajo escolar: el dato es propio, el incumplimiento es un evento y la alerta cierra el ciclo con acuse de recibo.</a:t>
+              <a:t>3:00 · Edgar. Empezar por la franja de arriba: son dos programas. A, el procesador de video, corre solo en el servidor, en segundo plano, cada vez que llega un video; B, la plataforma web, es lo que el usuario abre en el navegador. Se comunican solo por la base de datos: A escribe hallazgos, B los lee. Luego el flujo de izquierda a derecha. (1) Entra el video: la obra deja sus grabaciones en una carpeta y el sistema las toma solo; OpenCV lee el video, se queda con 5 cuadros por segundo, tapa las zonas que no se deben analizar y difumina rostros antes de guardar; cada cuadro queda fechado con la hora real de la grabación. (2) Se detecta y se sigue: RF-DETR es el modelo que marca personas, cascos y chalecos, entrenado con nuestras imágenes; es de licencia libre y por eso no usamos YOLO, cuya licencia AGPL obligaría a liberar todo el código. ByteTrack sigue a cada persona de un cuadro al siguiente con un número temporal: nunca sabemos quién es. ONNX Runtime es el motor que ejecuta el modelo ya entrenado, para que corra en cualquier computador sin tarjeta gráfica. (3) Se decide y se guarda: el motor de reglas, código propio, convierte recorridos en hallazgos según las reglas de la obra, medidas en segundos; PostgreSQL guarda todo, incluidas las detecciones cuadro a cuadro, y por eso se puede cambiar una regla y recalcular sin reprocesar video; Redis es una base de datos en memoria que usamos como fila de espera de los videos. (4) Se usa: FastAPI lee la base y entrega los datos a la web bajo un contrato acordado antes de programar; React es la web que construyen Miguel y Lian; la alerta llega sola al teléfono cuando se guarda un hallazgo grave, con acuse de recibo y un máximo de seis avisos por turno. Abajo, cómo se construye; la integración continua rechaza librerías AGPL. Cerrar con la última línea: el detector y las reglas deciden, la descripción con IA solo describe, y la unidad es el evento. Si preguntan por cámaras en vivo: RTSP es el protocolo de las cámaras IP; la versión 2 se conecta a cámaras en vez de leer archivos y se prueba desde la semana 6 simulando una cámara con un video grabado (MediaMTX).</a:t>
             </a:r>
           </a:p>
         </p:txBody>
@@ -22384,7 +22384,7 @@
                 <a:cs typeface="Calibri"/>
                 <a:sym typeface="Calibri"/>
               </a:rPr>
-              <a:t>Dos etapas: la Etapa 1 decide, la Etapa 2 solo describe. El evento, no el cuadro, es la unidad del sistema.</a:t>
+              <a:t>Cómo viaja el video hasta convertirse en un hallazgo con evidencia. En cada caja: una tecnología y lo que hace.</a:t>
             </a:r>
             <a:endParaRPr/>
           </a:p>
@@ -22424,8 +22424,8 @@
         </p:nvSpPr>
         <p:spPr>
           <a:xfrm>
-            <a:off x="365760" y="2423160"/>
-            <a:ext cx="4389120" cy="640080"/>
+            <a:off x="365760" y="2304288"/>
+            <a:ext cx="8494776" cy="274320"/>
           </a:xfrm>
           <a:prstGeom prst="roundRect">
             <a:avLst>
@@ -22465,17 +22465,26 @@
                 <a:spcPts val="0"/>
               </a:spcBef>
               <a:spcAft>
-                <a:spcPts val="200"/>
+                <a:spcPts val="0"/>
               </a:spcAft>
             </a:pPr>
             <a:r>
-              <a:rPr sz="1100" b="0" i="0">
+              <a:rPr sz="950" b="1">
+                <a:solidFill>
+                  <a:srgbClr val="1F3864"/>
+                </a:solidFill>
+                <a:latin typeface="Calibri"/>
+              </a:rPr>
+              <a:t>A · PROCESADOR DE VIDEO</a:t>
+            </a:r>
+            <a:r>
+              <a:rPr sz="950" b="0">
                 <a:solidFill>
                   <a:srgbClr val="1C1C1C"/>
                 </a:solidFill>
                 <a:latin typeface="Calibri"/>
               </a:rPr>
-              <a:t>FUENTE  ·  v1: carpeta vigilada  ·  v2: cámara RTSP  →  FrameSource (puerto)  ·  el reloj nace en la captura (capture_ts)</a:t>
+              <a:t>  ·  un programa que corre solo en el servidor cada vez que llega un video  ·  módulos propios: gepp-worker, gepp-vision, gepp-core</a:t>
             </a:r>
           </a:p>
         </p:txBody>
@@ -22488,8 +22497,8 @@
         </p:nvSpPr>
         <p:spPr>
           <a:xfrm>
-            <a:off x="5029200" y="2423160"/>
-            <a:ext cx="6720840" cy="640080"/>
+            <a:off x="9171432" y="2304288"/>
+            <a:ext cx="2624328" cy="274320"/>
           </a:xfrm>
           <a:prstGeom prst="roundRect">
             <a:avLst>
@@ -22497,11 +22506,11 @@
             </a:avLst>
           </a:prstGeom>
           <a:solidFill>
-            <a:srgbClr val="FFFFFF"/>
+            <a:srgbClr val="DDE5F0"/>
           </a:solidFill>
           <a:ln w="12700">
             <a:solidFill>
-              <a:srgbClr val="757070"/>
+              <a:srgbClr val="1F3864"/>
             </a:solidFill>
           </a:ln>
           <a:effectLst/>
@@ -22529,41 +22538,72 @@
                 <a:spcPts val="0"/>
               </a:spcBef>
               <a:spcAft>
-                <a:spcPts val="200"/>
+                <a:spcPts val="0"/>
               </a:spcAft>
             </a:pPr>
             <a:r>
-              <a:rPr sz="1000" b="0" i="0">
+              <a:rPr sz="950" b="1">
+                <a:solidFill>
+                  <a:srgbClr val="1F3864"/>
+                </a:solidFill>
+                <a:latin typeface="Calibri"/>
+              </a:rPr>
+              <a:t>B · PLATAFORMA WEB</a:t>
+            </a:r>
+            <a:r>
+              <a:rPr sz="950" b="0">
                 <a:solidFill>
                   <a:srgbClr val="1C1C1C"/>
                 </a:solidFill>
                 <a:latin typeface="Calibri"/>
               </a:rPr>
-              <a:t>Restricciones que ordenan el diseño: umbrales en segundos, nunca en cuadros  ·  5 fps  ·  reglas versionadas en la BD  ·  RF-DETR (Apache-2.0), sin licencias AGPL</a:t>
+              <a:t>  ·  gepp-api y la web</a:t>
             </a:r>
           </a:p>
         </p:txBody>
       </p:sp>
       <p:sp>
         <p:nvSpPr>
-          <p:cNvPr id="160" name="TextBox 159"/>
-          <p:cNvSpPr txBox="1"/>
+          <p:cNvPr id="160" name="Rounded Rectangle 159"/>
+          <p:cNvSpPr/>
           <p:nvPr/>
         </p:nvSpPr>
         <p:spPr>
           <a:xfrm>
-            <a:off x="2697480" y="3127248"/>
-            <a:ext cx="7315200" cy="274320"/>
+            <a:off x="365760" y="2633472"/>
+            <a:ext cx="2624328" cy="512064"/>
           </a:xfrm>
-          <a:prstGeom prst="rect">
-            <a:avLst/>
+          <a:prstGeom prst="roundRect">
+            <a:avLst>
+              <a:gd name="adj" fmla="val 8000"/>
+            </a:avLst>
           </a:prstGeom>
-          <a:noFill/>
+          <a:solidFill>
+            <a:srgbClr val="1F3864"/>
+          </a:solidFill>
+          <a:ln w="12700">
+            <a:solidFill>
+              <a:srgbClr val="1F3864"/>
+            </a:solidFill>
+          </a:ln>
+          <a:effectLst/>
         </p:spPr>
+        <p:style>
+          <a:lnRef idx="1">
+            <a:schemeClr val="accent1"/>
+          </a:lnRef>
+          <a:fillRef idx="3">
+            <a:schemeClr val="accent1"/>
+          </a:fillRef>
+          <a:effectRef idx="2">
+            <a:schemeClr val="accent1"/>
+          </a:effectRef>
+          <a:fontRef idx="minor">
+            <a:schemeClr val="lt1"/>
+          </a:fontRef>
+        </p:style>
         <p:txBody>
-          <a:bodyPr wrap="square" anchor="t" lIns="73152" rIns="73152" tIns="36576" bIns="36576">
-            <a:spAutoFit/>
-          </a:bodyPr>
+          <a:bodyPr rtlCol="0" anchor="ctr" wrap="square" tIns="54864" bIns="54864"/>
           <a:lstStyle/>
           <a:p>
             <a:pPr algn="l">
@@ -22571,17 +22611,36 @@
                 <a:spcPts val="0"/>
               </a:spcBef>
               <a:spcAft>
-                <a:spcPts val="0"/>
+                <a:spcPts val="300"/>
               </a:spcAft>
             </a:pPr>
             <a:r>
-              <a:rPr sz="1000" b="1" i="0">
+              <a:rPr sz="1200" b="1" i="0">
                 <a:solidFill>
-                  <a:srgbClr val="1F3864"/>
+                  <a:srgbClr val="FFFFFF"/>
                 </a:solidFill>
                 <a:latin typeface="Calibri"/>
               </a:rPr>
-              <a:t>ETAPA 1  ·  barata, siempre encendida  ·  DECIDE</a:t>
+              <a:t>1 · ENTRA EL VIDEO</a:t>
+            </a:r>
+          </a:p>
+          <a:p>
+            <a:pPr algn="l">
+              <a:spcBef>
+                <a:spcPts val="0"/>
+              </a:spcBef>
+              <a:spcAft>
+                <a:spcPts val="200"/>
+              </a:spcAft>
+            </a:pPr>
+            <a:r>
+              <a:rPr sz="900" b="0" i="0">
+                <a:solidFill>
+                  <a:srgbClr val="FFFFFF"/>
+                </a:solidFill>
+                <a:latin typeface="Calibri"/>
+              </a:rPr>
+              <a:t>cuándo: cada vez que llega un video</a:t>
             </a:r>
           </a:p>
         </p:txBody>
@@ -22594,8 +22653,8 @@
         </p:nvSpPr>
         <p:spPr>
           <a:xfrm>
-            <a:off x="365760" y="3401568"/>
-            <a:ext cx="2057400" cy="868680"/>
+            <a:off x="365760" y="3218688"/>
+            <a:ext cx="2624328" cy="1243584"/>
           </a:xfrm>
           <a:prstGeom prst="roundRect">
             <a:avLst>
@@ -22639,13 +22698,13 @@
               </a:spcAft>
             </a:pPr>
             <a:r>
-              <a:rPr sz="1200" b="1" i="0">
+              <a:rPr sz="1150" b="1" i="0">
                 <a:solidFill>
                   <a:srgbClr val="1F3864"/>
                 </a:solidFill>
                 <a:latin typeface="Calibri"/>
               </a:rPr>
-              <a:t>Muestreo 5 fps</a:t>
+              <a:t>Carpeta vigilada</a:t>
             </a:r>
           </a:p>
           <a:p>
@@ -22658,13 +22717,13 @@
               </a:spcAft>
             </a:pPr>
             <a:r>
-              <a:rPr sz="1000" b="0" i="0">
+              <a:rPr sz="950" b="0" i="0">
                 <a:solidFill>
                   <a:srgbClr val="1C1C1C"/>
                 </a:solidFill>
                 <a:latin typeface="Calibri"/>
               </a:rPr>
-              <a:t>máscaras de privacidad antes de inferir</a:t>
+              <a:t>La obra deja sus grabaciones en una carpeta y el sistema las toma solo. Cada cuadro queda fechado con la hora real en que se grabó. Más adelante: cámaras en vivo, con el mismo diseño.</a:t>
             </a:r>
           </a:p>
         </p:txBody>
@@ -22677,8 +22736,8 @@
         </p:nvSpPr>
         <p:spPr>
           <a:xfrm>
-            <a:off x="2697480" y="3401568"/>
-            <a:ext cx="2057400" cy="868680"/>
+            <a:off x="365760" y="4535424"/>
+            <a:ext cx="2624328" cy="1243584"/>
           </a:xfrm>
           <a:prstGeom prst="roundRect">
             <a:avLst>
@@ -22722,13 +22781,13 @@
               </a:spcAft>
             </a:pPr>
             <a:r>
-              <a:rPr sz="1200" b="1" i="0">
+              <a:rPr sz="1150" b="1" i="0">
                 <a:solidFill>
                   <a:srgbClr val="1F3864"/>
                 </a:solidFill>
                 <a:latin typeface="Calibri"/>
               </a:rPr>
-              <a:t>Detector RF-DETR</a:t>
+              <a:t>OpenCV</a:t>
             </a:r>
           </a:p>
           <a:p>
@@ -22741,13 +22800,13 @@
               </a:spcAft>
             </a:pPr>
             <a:r>
-              <a:rPr sz="1000" b="0" i="0">
+              <a:rPr sz="950" b="0" i="0">
                 <a:solidFill>
                   <a:srgbClr val="1C1C1C"/>
                 </a:solidFill>
                 <a:latin typeface="Calibri"/>
               </a:rPr>
-              <a:t>casco y chaleco · afinado con datos propios</a:t>
+              <a:t>Abre el video y se queda con 5 cuadros por segundo. Tapa las zonas que no se deben analizar y difumina los rostros antes de guardar cualquier imagen.</a:t>
             </a:r>
           </a:p>
         </p:txBody>
@@ -22760,8 +22819,135 @@
         </p:nvSpPr>
         <p:spPr>
           <a:xfrm>
-            <a:off x="5029200" y="3401568"/>
-            <a:ext cx="2057400" cy="868680"/>
+            <a:off x="3300984" y="2633472"/>
+            <a:ext cx="2624328" cy="512064"/>
+          </a:xfrm>
+          <a:prstGeom prst="roundRect">
+            <a:avLst>
+              <a:gd name="adj" fmla="val 8000"/>
+            </a:avLst>
+          </a:prstGeom>
+          <a:solidFill>
+            <a:srgbClr val="1F3864"/>
+          </a:solidFill>
+          <a:ln w="12700">
+            <a:solidFill>
+              <a:srgbClr val="1F3864"/>
+            </a:solidFill>
+          </a:ln>
+          <a:effectLst/>
+        </p:spPr>
+        <p:style>
+          <a:lnRef idx="1">
+            <a:schemeClr val="accent1"/>
+          </a:lnRef>
+          <a:fillRef idx="3">
+            <a:schemeClr val="accent1"/>
+          </a:fillRef>
+          <a:effectRef idx="2">
+            <a:schemeClr val="accent1"/>
+          </a:effectRef>
+          <a:fontRef idx="minor">
+            <a:schemeClr val="lt1"/>
+          </a:fontRef>
+        </p:style>
+        <p:txBody>
+          <a:bodyPr rtlCol="0" anchor="ctr" wrap="square" tIns="54864" bIns="54864"/>
+          <a:lstStyle/>
+          <a:p>
+            <a:pPr algn="l">
+              <a:spcBef>
+                <a:spcPts val="0"/>
+              </a:spcBef>
+              <a:spcAft>
+                <a:spcPts val="300"/>
+              </a:spcAft>
+            </a:pPr>
+            <a:r>
+              <a:rPr sz="1200" b="1" i="0">
+                <a:solidFill>
+                  <a:srgbClr val="FFFFFF"/>
+                </a:solidFill>
+                <a:latin typeface="Calibri"/>
+              </a:rPr>
+              <a:t>2 · SE DETECTA Y SE SIGUE</a:t>
+            </a:r>
+          </a:p>
+          <a:p>
+            <a:pPr algn="l">
+              <a:spcBef>
+                <a:spcPts val="0"/>
+              </a:spcBef>
+              <a:spcAft>
+                <a:spcPts val="200"/>
+              </a:spcAft>
+            </a:pPr>
+            <a:r>
+              <a:rPr sz="900" b="0" i="0">
+                <a:solidFill>
+                  <a:srgbClr val="FFFFFF"/>
+                </a:solidFill>
+                <a:latin typeface="Calibri"/>
+              </a:rPr>
+              <a:t>cuándo: enseguida, sin que nadie lo pida</a:t>
+            </a:r>
+          </a:p>
+        </p:txBody>
+      </p:sp>
+      <p:sp>
+        <p:nvSpPr>
+          <p:cNvPr id="164" name="Right Arrow 163"/>
+          <p:cNvSpPr/>
+          <p:nvPr/>
+        </p:nvSpPr>
+        <p:spPr>
+          <a:xfrm>
+            <a:off x="3017520" y="2734056"/>
+            <a:ext cx="256032" cy="310896"/>
+          </a:xfrm>
+          <a:prstGeom prst="rightArrow">
+            <a:avLst/>
+          </a:prstGeom>
+          <a:solidFill>
+            <a:srgbClr val="1F3864"/>
+          </a:solidFill>
+          <a:ln>
+            <a:noFill/>
+          </a:ln>
+          <a:effectLst/>
+        </p:spPr>
+        <p:style>
+          <a:lnRef idx="1">
+            <a:schemeClr val="accent1"/>
+          </a:lnRef>
+          <a:fillRef idx="3">
+            <a:schemeClr val="accent1"/>
+          </a:fillRef>
+          <a:effectRef idx="2">
+            <a:schemeClr val="accent1"/>
+          </a:effectRef>
+          <a:fontRef idx="minor">
+            <a:schemeClr val="lt1"/>
+          </a:fontRef>
+        </p:style>
+        <p:txBody>
+          <a:bodyPr rtlCol="0" anchor="ctr"/>
+          <a:lstStyle/>
+          <a:p>
+            <a:pPr algn="ctr"/>
+          </a:p>
+        </p:txBody>
+      </p:sp>
+      <p:sp>
+        <p:nvSpPr>
+          <p:cNvPr id="165" name="Rounded Rectangle 164"/>
+          <p:cNvSpPr/>
+          <p:nvPr/>
+        </p:nvSpPr>
+        <p:spPr>
+          <a:xfrm>
+            <a:off x="3300984" y="3218688"/>
+            <a:ext cx="2624328" cy="804672"/>
           </a:xfrm>
           <a:prstGeom prst="roundRect">
             <a:avLst>
@@ -22805,13 +22991,13 @@
               </a:spcAft>
             </a:pPr>
             <a:r>
-              <a:rPr sz="1200" b="1" i="0">
+              <a:rPr sz="1150" b="1" i="0">
                 <a:solidFill>
                   <a:srgbClr val="1F3864"/>
                 </a:solidFill>
                 <a:latin typeface="Calibri"/>
               </a:rPr>
-              <a:t>Seguidor ByteTrack</a:t>
+              <a:t>RF-DETR · el detector</a:t>
             </a:r>
           </a:p>
           <a:p>
@@ -22824,27 +23010,27 @@
               </a:spcAft>
             </a:pPr>
             <a:r>
-              <a:rPr sz="1000" b="0" i="0">
+              <a:rPr sz="950" b="0" i="0">
                 <a:solidFill>
                   <a:srgbClr val="1C1C1C"/>
                 </a:solidFill>
                 <a:latin typeface="Calibri"/>
               </a:rPr>
-              <a:t>track_id efímeros · sin reidentificación</a:t>
+              <a:t>Marca en cada cuadro dónde hay personas, cascos y chalecos. Se entrena con nuestras imágenes. Licencia libre, por eso no YOLO.</a:t>
             </a:r>
           </a:p>
         </p:txBody>
       </p:sp>
       <p:sp>
         <p:nvSpPr>
-          <p:cNvPr id="164" name="Rounded Rectangle 163"/>
+          <p:cNvPr id="166" name="Rounded Rectangle 165"/>
           <p:cNvSpPr/>
           <p:nvPr/>
         </p:nvSpPr>
         <p:spPr>
           <a:xfrm>
-            <a:off x="7360920" y="3401568"/>
-            <a:ext cx="2057400" cy="868680"/>
+            <a:off x="3300984" y="4096512"/>
+            <a:ext cx="2624328" cy="804672"/>
           </a:xfrm>
           <a:prstGeom prst="roundRect">
             <a:avLst>
@@ -22888,13 +23074,13 @@
               </a:spcAft>
             </a:pPr>
             <a:r>
-              <a:rPr sz="1200" b="1" i="0">
+              <a:rPr sz="1150" b="1" i="0">
                 <a:solidFill>
                   <a:srgbClr val="1F3864"/>
                 </a:solidFill>
                 <a:latin typeface="Calibri"/>
               </a:rPr>
-              <a:t>Detecciones crudas</a:t>
+              <a:t>ByteTrack · el seguidor</a:t>
             </a:r>
           </a:p>
           <a:p>
@@ -22907,27 +23093,27 @@
               </a:spcAft>
             </a:pPr>
             <a:r>
-              <a:rPr sz="1000" b="0" i="0">
+              <a:rPr sz="950" b="0" i="0">
                 <a:solidFill>
                   <a:srgbClr val="1C1C1C"/>
                 </a:solidFill>
                 <a:latin typeface="Calibri"/>
               </a:rPr>
-              <a:t>persistidas por track → recalcular sin GPU</a:t>
+              <a:t>Sigue a cada persona de un cuadro al siguiente y arma su recorrido. Le da un número temporal, nunca una identidad.</a:t>
             </a:r>
           </a:p>
         </p:txBody>
       </p:sp>
       <p:sp>
         <p:nvSpPr>
-          <p:cNvPr id="165" name="Rounded Rectangle 164"/>
+          <p:cNvPr id="167" name="Rounded Rectangle 166"/>
           <p:cNvSpPr/>
           <p:nvPr/>
         </p:nvSpPr>
         <p:spPr>
           <a:xfrm>
-            <a:off x="9692640" y="3401568"/>
-            <a:ext cx="2057400" cy="868680"/>
+            <a:off x="3300984" y="4974336"/>
+            <a:ext cx="2624328" cy="804672"/>
           </a:xfrm>
           <a:prstGeom prst="roundRect">
             <a:avLst>
@@ -22971,13 +23157,13 @@
               </a:spcAft>
             </a:pPr>
             <a:r>
-              <a:rPr sz="1200" b="1" i="0">
+              <a:rPr sz="1150" b="1" i="0">
                 <a:solidFill>
                   <a:srgbClr val="1F3864"/>
                 </a:solidFill>
                 <a:latin typeface="Calibri"/>
               </a:rPr>
-              <a:t>Motor de reglas</a:t>
+              <a:t>ONNX Runtime · la ejecución</a:t>
             </a:r>
           </a:p>
           <a:p>
@@ -22990,207 +23176,27 @@
               </a:spcAft>
             </a:pPr>
             <a:r>
-              <a:rPr sz="1000" b="0" i="0">
+              <a:rPr sz="950" b="0" i="0">
                 <a:solidFill>
                   <a:srgbClr val="1C1C1C"/>
                 </a:solidFill>
                 <a:latin typeface="Calibri"/>
               </a:rPr>
-              <a:t>zona · turno · severidad · segundos</a:t>
+              <a:t>Qué es: motor que ejecuta modelos ya entrenados. Para qué: que el modelo corra en cualquier computador, sin tarjeta gráfica.</a:t>
             </a:r>
           </a:p>
         </p:txBody>
       </p:sp>
-      <p:cxnSp>
-        <p:nvCxnSpPr>
-          <p:cNvPr id="166" name="Connector 165"/>
-          <p:cNvCxnSpPr/>
-          <p:nvPr/>
-        </p:nvCxnSpPr>
-        <p:spPr>
-          <a:xfrm>
-            <a:off x="2423160" y="3835908"/>
-            <a:ext cx="274320" cy="0"/>
-          </a:xfrm>
-          <a:prstGeom prst="line">
-            <a:avLst/>
-          </a:prstGeom>
-          <a:ln w="19050">
-            <a:solidFill>
-              <a:srgbClr val="1F3864"/>
-            </a:solidFill>
-            <a:tailEnd type="triangle" w="med" len="med"/>
-          </a:ln>
-        </p:spPr>
-        <p:style>
-          <a:lnRef idx="2">
-            <a:schemeClr val="accent1"/>
-          </a:lnRef>
-          <a:fillRef idx="0">
-            <a:schemeClr val="accent1"/>
-          </a:fillRef>
-          <a:effectRef idx="1">
-            <a:schemeClr val="accent1"/>
-          </a:effectRef>
-          <a:fontRef idx="minor">
-            <a:schemeClr val="tx1"/>
-          </a:fontRef>
-        </p:style>
-      </p:cxnSp>
-      <p:cxnSp>
-        <p:nvCxnSpPr>
-          <p:cNvPr id="167" name="Connector 166"/>
-          <p:cNvCxnSpPr/>
-          <p:nvPr/>
-        </p:nvCxnSpPr>
-        <p:spPr>
-          <a:xfrm>
-            <a:off x="4754880" y="3835908"/>
-            <a:ext cx="274320" cy="0"/>
-          </a:xfrm>
-          <a:prstGeom prst="line">
-            <a:avLst/>
-          </a:prstGeom>
-          <a:ln w="19050">
-            <a:solidFill>
-              <a:srgbClr val="1F3864"/>
-            </a:solidFill>
-            <a:tailEnd type="triangle" w="med" len="med"/>
-          </a:ln>
-        </p:spPr>
-        <p:style>
-          <a:lnRef idx="2">
-            <a:schemeClr val="accent1"/>
-          </a:lnRef>
-          <a:fillRef idx="0">
-            <a:schemeClr val="accent1"/>
-          </a:fillRef>
-          <a:effectRef idx="1">
-            <a:schemeClr val="accent1"/>
-          </a:effectRef>
-          <a:fontRef idx="minor">
-            <a:schemeClr val="tx1"/>
-          </a:fontRef>
-        </p:style>
-      </p:cxnSp>
-      <p:cxnSp>
-        <p:nvCxnSpPr>
-          <p:cNvPr id="168" name="Connector 167"/>
-          <p:cNvCxnSpPr/>
-          <p:nvPr/>
-        </p:nvCxnSpPr>
-        <p:spPr>
-          <a:xfrm>
-            <a:off x="7086600" y="3835908"/>
-            <a:ext cx="274320" cy="0"/>
-          </a:xfrm>
-          <a:prstGeom prst="line">
-            <a:avLst/>
-          </a:prstGeom>
-          <a:ln w="19050">
-            <a:solidFill>
-              <a:srgbClr val="1F3864"/>
-            </a:solidFill>
-            <a:tailEnd type="triangle" w="med" len="med"/>
-          </a:ln>
-        </p:spPr>
-        <p:style>
-          <a:lnRef idx="2">
-            <a:schemeClr val="accent1"/>
-          </a:lnRef>
-          <a:fillRef idx="0">
-            <a:schemeClr val="accent1"/>
-          </a:fillRef>
-          <a:effectRef idx="1">
-            <a:schemeClr val="accent1"/>
-          </a:effectRef>
-          <a:fontRef idx="minor">
-            <a:schemeClr val="tx1"/>
-          </a:fontRef>
-        </p:style>
-      </p:cxnSp>
-      <p:cxnSp>
-        <p:nvCxnSpPr>
-          <p:cNvPr id="169" name="Connector 168"/>
-          <p:cNvCxnSpPr/>
-          <p:nvPr/>
-        </p:nvCxnSpPr>
-        <p:spPr>
-          <a:xfrm>
-            <a:off x="9418320" y="3835908"/>
-            <a:ext cx="274320" cy="0"/>
-          </a:xfrm>
-          <a:prstGeom prst="line">
-            <a:avLst/>
-          </a:prstGeom>
-          <a:ln w="19050">
-            <a:solidFill>
-              <a:srgbClr val="1F3864"/>
-            </a:solidFill>
-            <a:tailEnd type="triangle" w="med" len="med"/>
-          </a:ln>
-        </p:spPr>
-        <p:style>
-          <a:lnRef idx="2">
-            <a:schemeClr val="accent1"/>
-          </a:lnRef>
-          <a:fillRef idx="0">
-            <a:schemeClr val="accent1"/>
-          </a:fillRef>
-          <a:effectRef idx="1">
-            <a:schemeClr val="accent1"/>
-          </a:effectRef>
-          <a:fontRef idx="minor">
-            <a:schemeClr val="tx1"/>
-          </a:fontRef>
-        </p:style>
-      </p:cxnSp>
-      <p:cxnSp>
-        <p:nvCxnSpPr>
-          <p:cNvPr id="170" name="Connector 169"/>
-          <p:cNvCxnSpPr/>
-          <p:nvPr/>
-        </p:nvCxnSpPr>
-        <p:spPr>
-          <a:xfrm>
-            <a:off x="1394460" y="3063239"/>
-            <a:ext cx="0" cy="338329"/>
-          </a:xfrm>
-          <a:prstGeom prst="line">
-            <a:avLst/>
-          </a:prstGeom>
-          <a:ln w="19050">
-            <a:solidFill>
-              <a:srgbClr val="1F3864"/>
-            </a:solidFill>
-            <a:tailEnd type="triangle" w="med" len="med"/>
-          </a:ln>
-        </p:spPr>
-        <p:style>
-          <a:lnRef idx="2">
-            <a:schemeClr val="accent1"/>
-          </a:lnRef>
-          <a:fillRef idx="0">
-            <a:schemeClr val="accent1"/>
-          </a:fillRef>
-          <a:effectRef idx="1">
-            <a:schemeClr val="accent1"/>
-          </a:effectRef>
-          <a:fontRef idx="minor">
-            <a:schemeClr val="tx1"/>
-          </a:fontRef>
-        </p:style>
-      </p:cxnSp>
       <p:sp>
         <p:nvSpPr>
-          <p:cNvPr id="171" name="Rounded Rectangle 170"/>
+          <p:cNvPr id="168" name="Rounded Rectangle 167"/>
           <p:cNvSpPr/>
           <p:nvPr/>
         </p:nvSpPr>
         <p:spPr>
           <a:xfrm>
-            <a:off x="365760" y="4709160"/>
-            <a:ext cx="11384280" cy="457200"/>
+            <a:off x="6236208" y="2633472"/>
+            <a:ext cx="2624328" cy="512064"/>
           </a:xfrm>
           <a:prstGeom prst="roundRect">
             <a:avLst>
@@ -23230,7 +23236,7 @@
                 <a:spcPts val="0"/>
               </a:spcBef>
               <a:spcAft>
-                <a:spcPts val="200"/>
+                <a:spcPts val="300"/>
               </a:spcAft>
             </a:pPr>
             <a:r>
@@ -23240,57 +23246,84 @@
                 </a:solidFill>
                 <a:latin typeface="Calibri"/>
               </a:rPr>
-              <a:t>HALLAZGO  ·  inicio  ·  término  ·  zona  ·  severidad  ·  evidencia        (un turno: 12 hallazgos, no 200.000 cuadros)</a:t>
+              <a:t>3 · SE DECIDE Y SE GUARDA</a:t>
+            </a:r>
+          </a:p>
+          <a:p>
+            <a:pPr algn="l">
+              <a:spcBef>
+                <a:spcPts val="0"/>
+              </a:spcBef>
+              <a:spcAft>
+                <a:spcPts val="200"/>
+              </a:spcAft>
+            </a:pPr>
+            <a:r>
+              <a:rPr sz="900" b="0" i="0">
+                <a:solidFill>
+                  <a:srgbClr val="FFFFFF"/>
+                </a:solidFill>
+                <a:latin typeface="Calibri"/>
+              </a:rPr>
+              <a:t>cuándo: al terminar cada video</a:t>
             </a:r>
           </a:p>
         </p:txBody>
       </p:sp>
-      <p:cxnSp>
-        <p:nvCxnSpPr>
-          <p:cNvPr id="172" name="Connector 171"/>
-          <p:cNvCxnSpPr/>
-          <p:nvPr/>
-        </p:nvCxnSpPr>
-        <p:spPr>
-          <a:xfrm>
-            <a:off x="10721340" y="4270248"/>
-            <a:ext cx="0" cy="438912"/>
-          </a:xfrm>
-          <a:prstGeom prst="line">
-            <a:avLst/>
-          </a:prstGeom>
-          <a:ln w="19050">
-            <a:solidFill>
-              <a:srgbClr val="1F3864"/>
-            </a:solidFill>
-            <a:tailEnd type="triangle" w="med" len="med"/>
-          </a:ln>
-        </p:spPr>
-        <p:style>
-          <a:lnRef idx="2">
-            <a:schemeClr val="accent1"/>
-          </a:lnRef>
-          <a:fillRef idx="0">
-            <a:schemeClr val="accent1"/>
-          </a:fillRef>
-          <a:effectRef idx="1">
-            <a:schemeClr val="accent1"/>
-          </a:effectRef>
-          <a:fontRef idx="minor">
-            <a:schemeClr val="tx1"/>
-          </a:fontRef>
-        </p:style>
-      </p:cxnSp>
       <p:sp>
         <p:nvSpPr>
-          <p:cNvPr id="173" name="Rounded Rectangle 172"/>
+          <p:cNvPr id="169" name="Right Arrow 168"/>
           <p:cNvSpPr/>
           <p:nvPr/>
         </p:nvSpPr>
         <p:spPr>
           <a:xfrm>
-            <a:off x="365760" y="5486400"/>
-            <a:ext cx="2057400" cy="914400"/>
+            <a:off x="5952744" y="2734056"/>
+            <a:ext cx="256032" cy="310896"/>
+          </a:xfrm>
+          <a:prstGeom prst="rightArrow">
+            <a:avLst/>
+          </a:prstGeom>
+          <a:solidFill>
+            <a:srgbClr val="1F3864"/>
+          </a:solidFill>
+          <a:ln>
+            <a:noFill/>
+          </a:ln>
+          <a:effectLst/>
+        </p:spPr>
+        <p:style>
+          <a:lnRef idx="1">
+            <a:schemeClr val="accent1"/>
+          </a:lnRef>
+          <a:fillRef idx="3">
+            <a:schemeClr val="accent1"/>
+          </a:fillRef>
+          <a:effectRef idx="2">
+            <a:schemeClr val="accent1"/>
+          </a:effectRef>
+          <a:fontRef idx="minor">
+            <a:schemeClr val="lt1"/>
+          </a:fontRef>
+        </p:style>
+        <p:txBody>
+          <a:bodyPr rtlCol="0" anchor="ctr"/>
+          <a:lstStyle/>
+          <a:p>
+            <a:pPr algn="ctr"/>
+          </a:p>
+        </p:txBody>
+      </p:sp>
+      <p:sp>
+        <p:nvSpPr>
+          <p:cNvPr id="170" name="Rounded Rectangle 169"/>
+          <p:cNvSpPr/>
+          <p:nvPr/>
+        </p:nvSpPr>
+        <p:spPr>
+          <a:xfrm>
+            <a:off x="6236208" y="3218688"/>
+            <a:ext cx="2624328" cy="804672"/>
           </a:xfrm>
           <a:prstGeom prst="roundRect">
             <a:avLst>
@@ -23334,13 +23367,13 @@
               </a:spcAft>
             </a:pPr>
             <a:r>
-              <a:rPr sz="1200" b="1" i="0">
+              <a:rPr sz="1150" b="1" i="0">
                 <a:solidFill>
                   <a:srgbClr val="1F3864"/>
                 </a:solidFill>
                 <a:latin typeface="Calibri"/>
               </a:rPr>
-              <a:t>Evidencia</a:t>
+              <a:t>Motor de reglas</a:t>
             </a:r>
           </a:p>
           <a:p>
@@ -23353,27 +23386,27 @@
               </a:spcAft>
             </a:pPr>
             <a:r>
-              <a:rPr sz="1000" b="0" i="0">
+              <a:rPr sz="950" b="0" i="0">
                 <a:solidFill>
                   <a:srgbClr val="1C1C1C"/>
                 </a:solidFill>
                 <a:latin typeface="Calibri"/>
               </a:rPr>
-              <a:t>recorte con rostro difuminado</a:t>
+              <a:t>Aplica las reglas de la obra: X segundos sin casco donde se exige crean un hallazgo con inicio, término, zona y severidad.</a:t>
             </a:r>
           </a:p>
         </p:txBody>
       </p:sp>
       <p:sp>
         <p:nvSpPr>
-          <p:cNvPr id="174" name="Rounded Rectangle 173"/>
+          <p:cNvPr id="171" name="Rounded Rectangle 170"/>
           <p:cNvSpPr/>
           <p:nvPr/>
         </p:nvSpPr>
         <p:spPr>
           <a:xfrm>
-            <a:off x="2697480" y="5486400"/>
-            <a:ext cx="2057400" cy="914400"/>
+            <a:off x="6236208" y="4096512"/>
+            <a:ext cx="2624328" cy="804672"/>
           </a:xfrm>
           <a:prstGeom prst="roundRect">
             <a:avLst>
@@ -23417,13 +23450,13 @@
               </a:spcAft>
             </a:pPr>
             <a:r>
-              <a:rPr sz="1200" b="1" i="0">
+              <a:rPr sz="1150" b="1" i="0">
                 <a:solidFill>
                   <a:srgbClr val="1F3864"/>
                 </a:solidFill>
                 <a:latin typeface="Calibri"/>
               </a:rPr>
-              <a:t>Notificación</a:t>
+              <a:t>PostgreSQL · la base de datos</a:t>
             </a:r>
           </a:p>
           <a:p>
@@ -23436,27 +23469,27 @@
               </a:spcAft>
             </a:pPr>
             <a:r>
-              <a:rPr sz="1000" b="0" i="0">
+              <a:rPr sz="950" b="0" i="0">
                 <a:solidFill>
                   <a:srgbClr val="1C1C1C"/>
                 </a:solidFill>
                 <a:latin typeface="Calibri"/>
               </a:rPr>
-              <a:t>cola de salida · acuse · supresión · ≤ 6 avisos por turno</a:t>
+              <a:t>Guarda hallazgos, detecciones cuadro a cuadro, reglas con historial y acuses. Es el punto de encuentro entre A y B.</a:t>
             </a:r>
           </a:p>
         </p:txBody>
       </p:sp>
       <p:sp>
         <p:nvSpPr>
-          <p:cNvPr id="175" name="Rounded Rectangle 174"/>
+          <p:cNvPr id="172" name="Rounded Rectangle 171"/>
           <p:cNvSpPr/>
           <p:nvPr/>
         </p:nvSpPr>
         <p:spPr>
           <a:xfrm>
-            <a:off x="5029200" y="5486400"/>
-            <a:ext cx="2057400" cy="914400"/>
+            <a:off x="6236208" y="4974336"/>
+            <a:ext cx="2624328" cy="804672"/>
           </a:xfrm>
           <a:prstGeom prst="roundRect">
             <a:avLst>
@@ -23500,13 +23533,13 @@
               </a:spcAft>
             </a:pPr>
             <a:r>
-              <a:rPr sz="1200" b="1" i="0">
+              <a:rPr sz="1150" b="1" i="0">
                 <a:solidFill>
                   <a:srgbClr val="1F3864"/>
                 </a:solidFill>
                 <a:latin typeface="Calibri"/>
               </a:rPr>
-              <a:t>Etapa 2 · VLM (extensión)</a:t>
+              <a:t>Redis · la fila de espera</a:t>
             </a:r>
           </a:p>
           <a:p>
@@ -23519,27 +23552,154 @@
               </a:spcAft>
             </a:pPr>
             <a:r>
-              <a:rPr sz="1000" b="0" i="0">
+              <a:rPr sz="950" b="0" i="0">
                 <a:solidFill>
                   <a:srgbClr val="1C1C1C"/>
                 </a:solidFill>
                 <a:latin typeface="Calibri"/>
               </a:rPr>
-              <a:t>describe el hallazgo · NO decide</a:t>
+              <a:t>Qué es: base de datos en memoria, muy rápida. Para qué: que los videos hagan fila y se procesen de a uno, sin perderse.</a:t>
             </a:r>
           </a:p>
         </p:txBody>
       </p:sp>
       <p:sp>
         <p:nvSpPr>
-          <p:cNvPr id="176" name="Rounded Rectangle 175"/>
+          <p:cNvPr id="173" name="Rounded Rectangle 172"/>
           <p:cNvSpPr/>
           <p:nvPr/>
         </p:nvSpPr>
         <p:spPr>
           <a:xfrm>
-            <a:off x="7360920" y="5486400"/>
-            <a:ext cx="2057400" cy="914400"/>
+            <a:off x="9171432" y="2633472"/>
+            <a:ext cx="2624328" cy="512064"/>
+          </a:xfrm>
+          <a:prstGeom prst="roundRect">
+            <a:avLst>
+              <a:gd name="adj" fmla="val 8000"/>
+            </a:avLst>
+          </a:prstGeom>
+          <a:solidFill>
+            <a:srgbClr val="1F3864"/>
+          </a:solidFill>
+          <a:ln w="12700">
+            <a:solidFill>
+              <a:srgbClr val="1F3864"/>
+            </a:solidFill>
+          </a:ln>
+          <a:effectLst/>
+        </p:spPr>
+        <p:style>
+          <a:lnRef idx="1">
+            <a:schemeClr val="accent1"/>
+          </a:lnRef>
+          <a:fillRef idx="3">
+            <a:schemeClr val="accent1"/>
+          </a:fillRef>
+          <a:effectRef idx="2">
+            <a:schemeClr val="accent1"/>
+          </a:effectRef>
+          <a:fontRef idx="minor">
+            <a:schemeClr val="lt1"/>
+          </a:fontRef>
+        </p:style>
+        <p:txBody>
+          <a:bodyPr rtlCol="0" anchor="ctr" wrap="square" tIns="54864" bIns="54864"/>
+          <a:lstStyle/>
+          <a:p>
+            <a:pPr algn="l">
+              <a:spcBef>
+                <a:spcPts val="0"/>
+              </a:spcBef>
+              <a:spcAft>
+                <a:spcPts val="300"/>
+              </a:spcAft>
+            </a:pPr>
+            <a:r>
+              <a:rPr sz="1200" b="1" i="0">
+                <a:solidFill>
+                  <a:srgbClr val="FFFFFF"/>
+                </a:solidFill>
+                <a:latin typeface="Calibri"/>
+              </a:rPr>
+              <a:t>4 · SE USA</a:t>
+            </a:r>
+          </a:p>
+          <a:p>
+            <a:pPr algn="l">
+              <a:spcBef>
+                <a:spcPts val="0"/>
+              </a:spcBef>
+              <a:spcAft>
+                <a:spcPts val="200"/>
+              </a:spcAft>
+            </a:pPr>
+            <a:r>
+              <a:rPr sz="900" b="0" i="0">
+                <a:solidFill>
+                  <a:srgbClr val="FFFFFF"/>
+                </a:solidFill>
+                <a:latin typeface="Calibri"/>
+              </a:rPr>
+              <a:t>cuándo: cuando el usuario abre el navegador</a:t>
+            </a:r>
+          </a:p>
+        </p:txBody>
+      </p:sp>
+      <p:sp>
+        <p:nvSpPr>
+          <p:cNvPr id="174" name="Right Arrow 173"/>
+          <p:cNvSpPr/>
+          <p:nvPr/>
+        </p:nvSpPr>
+        <p:spPr>
+          <a:xfrm>
+            <a:off x="8887967" y="2734056"/>
+            <a:ext cx="256032" cy="310896"/>
+          </a:xfrm>
+          <a:prstGeom prst="rightArrow">
+            <a:avLst/>
+          </a:prstGeom>
+          <a:solidFill>
+            <a:srgbClr val="1F3864"/>
+          </a:solidFill>
+          <a:ln>
+            <a:noFill/>
+          </a:ln>
+          <a:effectLst/>
+        </p:spPr>
+        <p:style>
+          <a:lnRef idx="1">
+            <a:schemeClr val="accent1"/>
+          </a:lnRef>
+          <a:fillRef idx="3">
+            <a:schemeClr val="accent1"/>
+          </a:fillRef>
+          <a:effectRef idx="2">
+            <a:schemeClr val="accent1"/>
+          </a:effectRef>
+          <a:fontRef idx="minor">
+            <a:schemeClr val="lt1"/>
+          </a:fontRef>
+        </p:style>
+        <p:txBody>
+          <a:bodyPr rtlCol="0" anchor="ctr"/>
+          <a:lstStyle/>
+          <a:p>
+            <a:pPr algn="ctr"/>
+          </a:p>
+        </p:txBody>
+      </p:sp>
+      <p:sp>
+        <p:nvSpPr>
+          <p:cNvPr id="175" name="Rounded Rectangle 174"/>
+          <p:cNvSpPr/>
+          <p:nvPr/>
+        </p:nvSpPr>
+        <p:spPr>
+          <a:xfrm>
+            <a:off x="9171432" y="3218688"/>
+            <a:ext cx="2624328" cy="804672"/>
           </a:xfrm>
           <a:prstGeom prst="roundRect">
             <a:avLst>
@@ -23583,13 +23743,13 @@
               </a:spcAft>
             </a:pPr>
             <a:r>
-              <a:rPr sz="1200" b="1" i="0">
+              <a:rPr sz="1150" b="1" i="0">
                 <a:solidFill>
                   <a:srgbClr val="1F3864"/>
                 </a:solidFill>
                 <a:latin typeface="Calibri"/>
               </a:rPr>
-              <a:t>API FastAPI</a:t>
+              <a:t>FastAPI · la API</a:t>
             </a:r>
           </a:p>
           <a:p>
@@ -23602,27 +23762,27 @@
               </a:spcAft>
             </a:pPr>
             <a:r>
-              <a:rPr sz="1000" b="0" i="0">
+              <a:rPr sz="950" b="0" i="0">
                 <a:solidFill>
                   <a:srgbClr val="1C1C1C"/>
                 </a:solidFill>
                 <a:latin typeface="Calibri"/>
               </a:rPr>
-              <a:t>PostgreSQL + Redis · contrato OpenAPI</a:t>
+              <a:t>Servicio que lee la base de datos y entrega la información a la web bajo un contrato fijo (OpenAPI). Corre sin GPU.</a:t>
             </a:r>
           </a:p>
         </p:txBody>
       </p:sp>
       <p:sp>
         <p:nvSpPr>
-          <p:cNvPr id="177" name="Rounded Rectangle 176"/>
+          <p:cNvPr id="176" name="Rounded Rectangle 175"/>
           <p:cNvSpPr/>
           <p:nvPr/>
         </p:nvSpPr>
         <p:spPr>
           <a:xfrm>
-            <a:off x="9692640" y="5486400"/>
-            <a:ext cx="2057400" cy="914400"/>
+            <a:off x="9171432" y="4096512"/>
+            <a:ext cx="2624328" cy="804672"/>
           </a:xfrm>
           <a:prstGeom prst="roundRect">
             <a:avLst>
@@ -23666,17 +23826,488 @@
               </a:spcAft>
             </a:pPr>
             <a:r>
-              <a:rPr sz="1200" b="1" i="0">
+              <a:rPr sz="1150" b="1" i="0">
                 <a:solidFill>
                   <a:srgbClr val="1F3864"/>
                 </a:solidFill>
                 <a:latin typeface="Calibri"/>
               </a:rPr>
-              <a:t>Web React</a:t>
+              <a:t>React · la web</a:t>
             </a:r>
           </a:p>
           <a:p>
             <a:pPr algn="l">
+              <a:spcBef>
+                <a:spcPts val="0"/>
+              </a:spcBef>
+              <a:spcAft>
+                <a:spcPts val="200"/>
+              </a:spcAft>
+            </a:pPr>
+            <a:r>
+              <a:rPr sz="950" b="0" i="0">
+                <a:solidFill>
+                  <a:srgbClr val="1C1C1C"/>
+                </a:solidFill>
+                <a:latin typeface="Calibri"/>
+              </a:rPr>
+              <a:t>Bandeja de hallazgos, visor de evidencia, reglas y tablero. Miguel y Lian la construyen contra un servidor simulado (Prism).</a:t>
+            </a:r>
+          </a:p>
+        </p:txBody>
+      </p:sp>
+      <p:sp>
+        <p:nvSpPr>
+          <p:cNvPr id="177" name="Rounded Rectangle 176"/>
+          <p:cNvSpPr/>
+          <p:nvPr/>
+        </p:nvSpPr>
+        <p:spPr>
+          <a:xfrm>
+            <a:off x="9171432" y="4974336"/>
+            <a:ext cx="2624328" cy="804672"/>
+          </a:xfrm>
+          <a:prstGeom prst="roundRect">
+            <a:avLst>
+              <a:gd name="adj" fmla="val 8000"/>
+            </a:avLst>
+          </a:prstGeom>
+          <a:solidFill>
+            <a:srgbClr val="F2F2F2"/>
+          </a:solidFill>
+          <a:ln w="12700">
+            <a:solidFill>
+              <a:srgbClr val="1F3864"/>
+            </a:solidFill>
+          </a:ln>
+          <a:effectLst/>
+        </p:spPr>
+        <p:style>
+          <a:lnRef idx="1">
+            <a:schemeClr val="accent1"/>
+          </a:lnRef>
+          <a:fillRef idx="3">
+            <a:schemeClr val="accent1"/>
+          </a:fillRef>
+          <a:effectRef idx="2">
+            <a:schemeClr val="accent1"/>
+          </a:effectRef>
+          <a:fontRef idx="minor">
+            <a:schemeClr val="lt1"/>
+          </a:fontRef>
+        </p:style>
+        <p:txBody>
+          <a:bodyPr rtlCol="0" anchor="t" wrap="square" tIns="54864" bIns="54864"/>
+          <a:lstStyle/>
+          <a:p>
+            <a:pPr algn="l">
+              <a:spcBef>
+                <a:spcPts val="0"/>
+              </a:spcBef>
+              <a:spcAft>
+                <a:spcPts val="300"/>
+              </a:spcAft>
+            </a:pPr>
+            <a:r>
+              <a:rPr sz="1150" b="1" i="0">
+                <a:solidFill>
+                  <a:srgbClr val="1F3864"/>
+                </a:solidFill>
+                <a:latin typeface="Calibri"/>
+              </a:rPr>
+              <a:t>Telegram o correo · la alerta</a:t>
+            </a:r>
+          </a:p>
+          <a:p>
+            <a:pPr algn="l">
+              <a:spcBef>
+                <a:spcPts val="0"/>
+              </a:spcBef>
+              <a:spcAft>
+                <a:spcPts val="200"/>
+              </a:spcAft>
+            </a:pPr>
+            <a:r>
+              <a:rPr sz="950" b="0" i="0">
+                <a:solidFill>
+                  <a:srgbClr val="1C1C1C"/>
+                </a:solidFill>
+                <a:latin typeface="Calibri"/>
+              </a:rPr>
+              <a:t>Llega sola al teléfono cuando se guarda un hallazgo grave. Acuse de recibo y máximo 6 avisos por turno.</a:t>
+            </a:r>
+          </a:p>
+        </p:txBody>
+      </p:sp>
+      <p:sp>
+        <p:nvSpPr>
+          <p:cNvPr id="178" name="Rounded Rectangle 177"/>
+          <p:cNvSpPr/>
+          <p:nvPr/>
+        </p:nvSpPr>
+        <p:spPr>
+          <a:xfrm>
+            <a:off x="365760" y="5852160"/>
+            <a:ext cx="11430000" cy="512064"/>
+          </a:xfrm>
+          <a:prstGeom prst="roundRect">
+            <a:avLst>
+              <a:gd name="adj" fmla="val 8000"/>
+            </a:avLst>
+          </a:prstGeom>
+          <a:solidFill>
+            <a:srgbClr val="DDE5F0"/>
+          </a:solidFill>
+          <a:ln w="12700">
+            <a:solidFill>
+              <a:srgbClr val="1F3864"/>
+            </a:solidFill>
+          </a:ln>
+          <a:effectLst/>
+        </p:spPr>
+        <p:style>
+          <a:lnRef idx="1">
+            <a:schemeClr val="accent1"/>
+          </a:lnRef>
+          <a:fillRef idx="3">
+            <a:schemeClr val="accent1"/>
+          </a:fillRef>
+          <a:effectRef idx="2">
+            <a:schemeClr val="accent1"/>
+          </a:effectRef>
+          <a:fontRef idx="minor">
+            <a:schemeClr val="lt1"/>
+          </a:fontRef>
+        </p:style>
+        <p:txBody>
+          <a:bodyPr rtlCol="0" anchor="t" wrap="square" tIns="54864" bIns="54864"/>
+          <a:lstStyle/>
+          <a:p>
+            <a:pPr algn="ctr"/>
+          </a:p>
+        </p:txBody>
+      </p:sp>
+      <p:sp>
+        <p:nvSpPr>
+          <p:cNvPr id="179" name="TextBox 178"/>
+          <p:cNvSpPr txBox="1"/>
+          <p:nvPr/>
+        </p:nvSpPr>
+        <p:spPr>
+          <a:xfrm>
+            <a:off x="411480" y="5852160"/>
+            <a:ext cx="1463040" cy="512064"/>
+          </a:xfrm>
+          <a:prstGeom prst="rect">
+            <a:avLst/>
+          </a:prstGeom>
+          <a:noFill/>
+        </p:spPr>
+        <p:txBody>
+          <a:bodyPr wrap="square" anchor="ctr" lIns="73152" rIns="73152" tIns="36576" bIns="36576">
+            <a:spAutoFit/>
+          </a:bodyPr>
+          <a:lstStyle/>
+          <a:p>
+            <a:pPr algn="l">
+              <a:spcBef>
+                <a:spcPts val="0"/>
+              </a:spcBef>
+              <a:spcAft>
+                <a:spcPts val="0"/>
+              </a:spcAft>
+            </a:pPr>
+            <a:r>
+              <a:rPr sz="1100" b="1" i="0">
+                <a:solidFill>
+                  <a:srgbClr val="1F3864"/>
+                </a:solidFill>
+                <a:latin typeface="Calibri"/>
+              </a:rPr>
+              <a:t>CÓMO SE</a:t>
+            </a:r>
+          </a:p>
+          <a:p>
+            <a:pPr algn="l">
+              <a:spcBef>
+                <a:spcPts val="0"/>
+              </a:spcBef>
+              <a:spcAft>
+                <a:spcPts val="0"/>
+              </a:spcAft>
+            </a:pPr>
+            <a:r>
+              <a:rPr sz="1100" b="1" i="0">
+                <a:solidFill>
+                  <a:srgbClr val="1F3864"/>
+                </a:solidFill>
+                <a:latin typeface="Calibri"/>
+              </a:rPr>
+              <a:t>CONSTRUYE</a:t>
+            </a:r>
+          </a:p>
+        </p:txBody>
+      </p:sp>
+      <p:sp>
+        <p:nvSpPr>
+          <p:cNvPr id="180" name="TextBox 179"/>
+          <p:cNvSpPr txBox="1"/>
+          <p:nvPr/>
+        </p:nvSpPr>
+        <p:spPr>
+          <a:xfrm>
+            <a:off x="1920240" y="5870448"/>
+            <a:ext cx="3291840" cy="475488"/>
+          </a:xfrm>
+          <a:prstGeom prst="rect">
+            <a:avLst/>
+          </a:prstGeom>
+          <a:noFill/>
+        </p:spPr>
+        <p:txBody>
+          <a:bodyPr wrap="square" anchor="ctr" lIns="73152" rIns="73152" tIns="36576" bIns="36576">
+            <a:spAutoFit/>
+          </a:bodyPr>
+          <a:lstStyle/>
+          <a:p>
+            <a:pPr algn="l">
+              <a:spcBef>
+                <a:spcPts val="0"/>
+              </a:spcBef>
+              <a:spcAft>
+                <a:spcPts val="100"/>
+              </a:spcAft>
+            </a:pPr>
+            <a:r>
+              <a:rPr sz="900" b="1">
+                <a:solidFill>
+                  <a:srgbClr val="1F3864"/>
+                </a:solidFill>
+                <a:latin typeface="Calibri"/>
+              </a:rPr>
+              <a:t>uv</a:t>
+            </a:r>
+            <a:r>
+              <a:rPr sz="900" b="0">
+                <a:solidFill>
+                  <a:srgbClr val="1C1C1C"/>
+                </a:solidFill>
+                <a:latin typeface="Calibri"/>
+              </a:rPr>
+              <a:t> · un solo entorno Python para todos los módulos</a:t>
+            </a:r>
+          </a:p>
+          <a:p>
+            <a:pPr algn="l">
+              <a:spcBef>
+                <a:spcPts val="0"/>
+              </a:spcBef>
+              <a:spcAft>
+                <a:spcPts val="100"/>
+              </a:spcAft>
+            </a:pPr>
+            <a:r>
+              <a:rPr sz="900" b="1">
+                <a:solidFill>
+                  <a:srgbClr val="1F3864"/>
+                </a:solidFill>
+                <a:latin typeface="Calibri"/>
+              </a:rPr>
+              <a:t>pytest · mypy · ruff</a:t>
+            </a:r>
+            <a:r>
+              <a:rPr sz="900" b="0">
+                <a:solidFill>
+                  <a:srgbClr val="1C1C1C"/>
+                </a:solidFill>
+                <a:latin typeface="Calibri"/>
+              </a:rPr>
+              <a:t> · pruebas, tipos y estilo automáticos</a:t>
+            </a:r>
+          </a:p>
+        </p:txBody>
+      </p:sp>
+      <p:sp>
+        <p:nvSpPr>
+          <p:cNvPr id="181" name="TextBox 180"/>
+          <p:cNvSpPr txBox="1"/>
+          <p:nvPr/>
+        </p:nvSpPr>
+        <p:spPr>
+          <a:xfrm>
+            <a:off x="5212080" y="5870448"/>
+            <a:ext cx="3291840" cy="475488"/>
+          </a:xfrm>
+          <a:prstGeom prst="rect">
+            <a:avLst/>
+          </a:prstGeom>
+          <a:noFill/>
+        </p:spPr>
+        <p:txBody>
+          <a:bodyPr wrap="square" anchor="ctr" lIns="73152" rIns="73152" tIns="36576" bIns="36576">
+            <a:spAutoFit/>
+          </a:bodyPr>
+          <a:lstStyle/>
+          <a:p>
+            <a:pPr algn="l">
+              <a:spcBef>
+                <a:spcPts val="0"/>
+              </a:spcBef>
+              <a:spcAft>
+                <a:spcPts val="100"/>
+              </a:spcAft>
+            </a:pPr>
+            <a:r>
+              <a:rPr sz="900" b="1">
+                <a:solidFill>
+                  <a:srgbClr val="1F3864"/>
+                </a:solidFill>
+                <a:latin typeface="Calibri"/>
+              </a:rPr>
+              <a:t>GitHub Actions</a:t>
+            </a:r>
+            <a:r>
+              <a:rPr sz="900" b="0">
+                <a:solidFill>
+                  <a:srgbClr val="1C1C1C"/>
+                </a:solidFill>
+                <a:latin typeface="Calibri"/>
+              </a:rPr>
+              <a:t> · prueba cada cambio; rechaza librerías AGPL (como YOLO), que obligarían a liberar todo el código</a:t>
+            </a:r>
+          </a:p>
+          <a:p>
+            <a:pPr algn="l">
+              <a:spcBef>
+                <a:spcPts val="0"/>
+              </a:spcBef>
+              <a:spcAft>
+                <a:spcPts val="100"/>
+              </a:spcAft>
+            </a:pPr>
+            <a:r>
+              <a:rPr sz="900" b="1">
+                <a:solidFill>
+                  <a:srgbClr val="1F3864"/>
+                </a:solidFill>
+                <a:latin typeface="Calibri"/>
+              </a:rPr>
+              <a:t>Docker Compose</a:t>
+            </a:r>
+            <a:r>
+              <a:rPr sz="900" b="0">
+                <a:solidFill>
+                  <a:srgbClr val="1C1C1C"/>
+                </a:solidFill>
+                <a:latin typeface="Calibri"/>
+              </a:rPr>
+              <a:t> · PostgreSQL y Redis con un comando</a:t>
+            </a:r>
+          </a:p>
+        </p:txBody>
+      </p:sp>
+      <p:sp>
+        <p:nvSpPr>
+          <p:cNvPr id="182" name="TextBox 181"/>
+          <p:cNvSpPr txBox="1"/>
+          <p:nvPr/>
+        </p:nvSpPr>
+        <p:spPr>
+          <a:xfrm>
+            <a:off x="8503920" y="5870448"/>
+            <a:ext cx="3291840" cy="475488"/>
+          </a:xfrm>
+          <a:prstGeom prst="rect">
+            <a:avLst/>
+          </a:prstGeom>
+          <a:noFill/>
+        </p:spPr>
+        <p:txBody>
+          <a:bodyPr wrap="square" anchor="ctr" lIns="73152" rIns="73152" tIns="36576" bIns="36576">
+            <a:spAutoFit/>
+          </a:bodyPr>
+          <a:lstStyle/>
+          <a:p>
+            <a:pPr algn="l">
+              <a:spcBef>
+                <a:spcPts val="0"/>
+              </a:spcBef>
+              <a:spcAft>
+                <a:spcPts val="100"/>
+              </a:spcAft>
+            </a:pPr>
+            <a:r>
+              <a:rPr sz="900" b="1">
+                <a:solidFill>
+                  <a:srgbClr val="1F3864"/>
+                </a:solidFill>
+                <a:latin typeface="Calibri"/>
+              </a:rPr>
+              <a:t>Prism</a:t>
+            </a:r>
+            <a:r>
+              <a:rPr sz="900" b="0">
+                <a:solidFill>
+                  <a:srgbClr val="1C1C1C"/>
+                </a:solidFill>
+                <a:latin typeface="Calibri"/>
+              </a:rPr>
+              <a:t> · servidor simulado: la web avanza sin backend</a:t>
+            </a:r>
+          </a:p>
+          <a:p>
+            <a:pPr algn="l">
+              <a:spcBef>
+                <a:spcPts val="0"/>
+              </a:spcBef>
+              <a:spcAft>
+                <a:spcPts val="100"/>
+              </a:spcAft>
+            </a:pPr>
+            <a:r>
+              <a:rPr sz="900" b="1">
+                <a:solidFill>
+                  <a:srgbClr val="1F3864"/>
+                </a:solidFill>
+                <a:latin typeface="Calibri"/>
+              </a:rPr>
+              <a:t>CVAT</a:t>
+            </a:r>
+            <a:r>
+              <a:rPr sz="900" b="0">
+                <a:solidFill>
+                  <a:srgbClr val="1C1C1C"/>
+                </a:solidFill>
+                <a:latin typeface="Calibri"/>
+              </a:rPr>
+              <a:t> · etiquetado de imágenes en nuestro computador</a:t>
+            </a:r>
+          </a:p>
+        </p:txBody>
+      </p:sp>
+      <p:sp>
+        <p:nvSpPr>
+          <p:cNvPr id="183" name="TextBox 182"/>
+          <p:cNvSpPr txBox="1"/>
+          <p:nvPr/>
+        </p:nvSpPr>
+        <p:spPr>
+          <a:xfrm>
+            <a:off x="365760" y="6400800"/>
+            <a:ext cx="11430000" cy="457200"/>
+          </a:xfrm>
+          <a:prstGeom prst="rect">
+            <a:avLst/>
+          </a:prstGeom>
+          <a:noFill/>
+        </p:spPr>
+        <p:txBody>
+          <a:bodyPr wrap="square" anchor="t" lIns="73152" rIns="73152" tIns="36576" bIns="36576">
+            <a:spAutoFit/>
+          </a:bodyPr>
+          <a:lstStyle/>
+          <a:p>
+            <a:pPr algn="ctr">
               <a:spcBef>
                 <a:spcPts val="0"/>
               </a:spcBef>
@@ -23691,191 +24322,30 @@
                 </a:solidFill>
                 <a:latin typeface="Calibri"/>
               </a:rPr>
-              <a:t>bandeja · visor · reglas · analítica</a:t>
+              <a:t>A y B son programas separados que solo se comunican por la base de datos: A escribe los hallazgos, B los lee y los muestra. A trabaja siempre, sin que nadie lo abra; B se usa cuando se necesita.</a:t>
+            </a:r>
+          </a:p>
+          <a:p>
+            <a:pPr algn="ctr">
+              <a:spcBef>
+                <a:spcPts val="0"/>
+              </a:spcBef>
+              <a:spcAft>
+                <a:spcPts val="0"/>
+              </a:spcAft>
+            </a:pPr>
+            <a:r>
+              <a:rPr sz="1000" b="1" i="0">
+                <a:solidFill>
+                  <a:srgbClr val="1F3864"/>
+                </a:solidFill>
+                <a:latin typeface="Calibri"/>
+              </a:rPr>
+              <a:t>El detector y las reglas deciden; la descripción con IA (extensión futura) solo describe.   ·   La unidad es el evento: un turno son 12 hallazgos, no 200.000 cuadros.</a:t>
             </a:r>
           </a:p>
         </p:txBody>
       </p:sp>
-      <p:cxnSp>
-        <p:nvCxnSpPr>
-          <p:cNvPr id="178" name="Connector 177"/>
-          <p:cNvCxnSpPr/>
-          <p:nvPr/>
-        </p:nvCxnSpPr>
-        <p:spPr>
-          <a:xfrm>
-            <a:off x="1394460" y="5166360"/>
-            <a:ext cx="0" cy="320040"/>
-          </a:xfrm>
-          <a:prstGeom prst="line">
-            <a:avLst/>
-          </a:prstGeom>
-          <a:ln w="19050">
-            <a:solidFill>
-              <a:srgbClr val="1F3864"/>
-            </a:solidFill>
-            <a:tailEnd type="triangle" w="med" len="med"/>
-          </a:ln>
-        </p:spPr>
-        <p:style>
-          <a:lnRef idx="2">
-            <a:schemeClr val="accent1"/>
-          </a:lnRef>
-          <a:fillRef idx="0">
-            <a:schemeClr val="accent1"/>
-          </a:fillRef>
-          <a:effectRef idx="1">
-            <a:schemeClr val="accent1"/>
-          </a:effectRef>
-          <a:fontRef idx="minor">
-            <a:schemeClr val="tx1"/>
-          </a:fontRef>
-        </p:style>
-      </p:cxnSp>
-      <p:cxnSp>
-        <p:nvCxnSpPr>
-          <p:cNvPr id="179" name="Connector 178"/>
-          <p:cNvCxnSpPr/>
-          <p:nvPr/>
-        </p:nvCxnSpPr>
-        <p:spPr>
-          <a:xfrm>
-            <a:off x="3726180" y="5166360"/>
-            <a:ext cx="0" cy="320040"/>
-          </a:xfrm>
-          <a:prstGeom prst="line">
-            <a:avLst/>
-          </a:prstGeom>
-          <a:ln w="19050">
-            <a:solidFill>
-              <a:srgbClr val="1F3864"/>
-            </a:solidFill>
-            <a:tailEnd type="triangle" w="med" len="med"/>
-          </a:ln>
-        </p:spPr>
-        <p:style>
-          <a:lnRef idx="2">
-            <a:schemeClr val="accent1"/>
-          </a:lnRef>
-          <a:fillRef idx="0">
-            <a:schemeClr val="accent1"/>
-          </a:fillRef>
-          <a:effectRef idx="1">
-            <a:schemeClr val="accent1"/>
-          </a:effectRef>
-          <a:fontRef idx="minor">
-            <a:schemeClr val="tx1"/>
-          </a:fontRef>
-        </p:style>
-      </p:cxnSp>
-      <p:cxnSp>
-        <p:nvCxnSpPr>
-          <p:cNvPr id="180" name="Connector 179"/>
-          <p:cNvCxnSpPr/>
-          <p:nvPr/>
-        </p:nvCxnSpPr>
-        <p:spPr>
-          <a:xfrm>
-            <a:off x="6057900" y="5166360"/>
-            <a:ext cx="0" cy="320040"/>
-          </a:xfrm>
-          <a:prstGeom prst="line">
-            <a:avLst/>
-          </a:prstGeom>
-          <a:ln w="19050">
-            <a:solidFill>
-              <a:srgbClr val="1F3864"/>
-            </a:solidFill>
-            <a:tailEnd type="triangle" w="med" len="med"/>
-          </a:ln>
-        </p:spPr>
-        <p:style>
-          <a:lnRef idx="2">
-            <a:schemeClr val="accent1"/>
-          </a:lnRef>
-          <a:fillRef idx="0">
-            <a:schemeClr val="accent1"/>
-          </a:fillRef>
-          <a:effectRef idx="1">
-            <a:schemeClr val="accent1"/>
-          </a:effectRef>
-          <a:fontRef idx="minor">
-            <a:schemeClr val="tx1"/>
-          </a:fontRef>
-        </p:style>
-      </p:cxnSp>
-      <p:cxnSp>
-        <p:nvCxnSpPr>
-          <p:cNvPr id="181" name="Connector 180"/>
-          <p:cNvCxnSpPr/>
-          <p:nvPr/>
-        </p:nvCxnSpPr>
-        <p:spPr>
-          <a:xfrm>
-            <a:off x="8389620" y="5166360"/>
-            <a:ext cx="0" cy="320040"/>
-          </a:xfrm>
-          <a:prstGeom prst="line">
-            <a:avLst/>
-          </a:prstGeom>
-          <a:ln w="19050">
-            <a:solidFill>
-              <a:srgbClr val="1F3864"/>
-            </a:solidFill>
-            <a:tailEnd type="triangle" w="med" len="med"/>
-          </a:ln>
-        </p:spPr>
-        <p:style>
-          <a:lnRef idx="2">
-            <a:schemeClr val="accent1"/>
-          </a:lnRef>
-          <a:fillRef idx="0">
-            <a:schemeClr val="accent1"/>
-          </a:fillRef>
-          <a:effectRef idx="1">
-            <a:schemeClr val="accent1"/>
-          </a:effectRef>
-          <a:fontRef idx="minor">
-            <a:schemeClr val="tx1"/>
-          </a:fontRef>
-        </p:style>
-      </p:cxnSp>
-      <p:cxnSp>
-        <p:nvCxnSpPr>
-          <p:cNvPr id="182" name="Connector 181"/>
-          <p:cNvCxnSpPr/>
-          <p:nvPr/>
-        </p:nvCxnSpPr>
-        <p:spPr>
-          <a:xfrm>
-            <a:off x="9418320" y="5943600"/>
-            <a:ext cx="274320" cy="0"/>
-          </a:xfrm>
-          <a:prstGeom prst="line">
-            <a:avLst/>
-          </a:prstGeom>
-          <a:ln w="19050">
-            <a:solidFill>
-              <a:srgbClr val="1F3864"/>
-            </a:solidFill>
-            <a:tailEnd type="triangle" w="med" len="med"/>
-          </a:ln>
-        </p:spPr>
-        <p:style>
-          <a:lnRef idx="2">
-            <a:schemeClr val="accent1"/>
-          </a:lnRef>
-          <a:fillRef idx="0">
-            <a:schemeClr val="accent1"/>
-          </a:fillRef>
-          <a:effectRef idx="1">
-            <a:schemeClr val="accent1"/>
-          </a:effectRef>
-          <a:fontRef idx="minor">
-            <a:schemeClr val="tx1"/>
-          </a:fontRef>
-        </p:style>
-      </p:cxnSp>
     </p:spTree>
   </p:cSld>
   <p:clrMapOvr>

</xml_diff>